<commit_message>
Ajout de la presentation de l'Auditeur (PDF et PPTX)
</commit_message>
<xml_diff>
--- a/6-Diriger un projet de données/Auditeur_Coherence_Medicale/5-Presentation/Auditeur_Coherence_Medicale_Presentation.pptx
+++ b/6-Diriger un projet de données/Auditeur_Coherence_Medicale/5-Presentation/Auditeur_Coherence_Medicale_Presentation.pptx
@@ -5,7 +5,7 @@
     <p:sldMasterId id="2147483648" r:id="rId1"/>
   </p:sldMasterIdLst>
   <p:notesMasterIdLst>
-    <p:notesMasterId r:id="rId14"/>
+    <p:notesMasterId r:id="rId15"/>
   </p:notesMasterIdLst>
   <p:sldIdLst>
     <p:sldId id="256" r:id="rId2"/>
@@ -14,12 +14,13 @@
     <p:sldId id="258" r:id="rId5"/>
     <p:sldId id="259" r:id="rId6"/>
     <p:sldId id="260" r:id="rId7"/>
-    <p:sldId id="261" r:id="rId8"/>
-    <p:sldId id="277" r:id="rId9"/>
-    <p:sldId id="276" r:id="rId10"/>
-    <p:sldId id="265" r:id="rId11"/>
-    <p:sldId id="266" r:id="rId12"/>
-    <p:sldId id="267" r:id="rId13"/>
+    <p:sldId id="278" r:id="rId8"/>
+    <p:sldId id="261" r:id="rId9"/>
+    <p:sldId id="277" r:id="rId10"/>
+    <p:sldId id="276" r:id="rId11"/>
+    <p:sldId id="265" r:id="rId12"/>
+    <p:sldId id="266" r:id="rId13"/>
+    <p:sldId id="267" r:id="rId14"/>
   </p:sldIdLst>
   <p:sldSz cx="12192000" cy="6858000"/>
   <p:notesSz cx="6858000" cy="12192000"/>
@@ -675,7 +676,13 @@
   <p:cSld>
     <p:spTree>
       <p:nvGrpSpPr>
-        <p:cNvPr id="1" name=""/>
+        <p:cNvPr id="1" name="">
+          <a:extLst>
+            <a:ext uri="{FF2B5EF4-FFF2-40B4-BE49-F238E27FC236}">
+              <a16:creationId xmlns:a16="http://schemas.microsoft.com/office/drawing/2014/main" id="{D39B2396-5488-9F4F-8893-CD4766E0D863}"/>
+            </a:ext>
+          </a:extLst>
+        </p:cNvPr>
         <p:cNvGrpSpPr/>
         <p:nvPr/>
       </p:nvGrpSpPr>
@@ -689,7 +696,13 @@
       </p:grpSpPr>
       <p:sp>
         <p:nvSpPr>
-          <p:cNvPr id="2" name="Slide Image Placeholder 1"/>
+          <p:cNvPr id="2" name="Slide Image Placeholder 1">
+            <a:extLst>
+              <a:ext uri="{FF2B5EF4-FFF2-40B4-BE49-F238E27FC236}">
+                <a16:creationId xmlns:a16="http://schemas.microsoft.com/office/drawing/2014/main" id="{5AF860BD-C3D4-44B6-8907-3CB003688ADC}"/>
+              </a:ext>
+            </a:extLst>
+          </p:cNvPr>
           <p:cNvSpPr>
             <a:spLocks noGrp="1" noRot="1" noChangeAspect="1"/>
           </p:cNvSpPr>
@@ -708,7 +721,13 @@
       </p:sp>
       <p:sp>
         <p:nvSpPr>
-          <p:cNvPr id="3" name="Notes Placeholder 2"/>
+          <p:cNvPr id="3" name="Notes Placeholder 2">
+            <a:extLst>
+              <a:ext uri="{FF2B5EF4-FFF2-40B4-BE49-F238E27FC236}">
+                <a16:creationId xmlns:a16="http://schemas.microsoft.com/office/drawing/2014/main" id="{18AC209A-05DC-98A5-2678-2FF4B78731A9}"/>
+              </a:ext>
+            </a:extLst>
+          </p:cNvPr>
           <p:cNvSpPr>
             <a:spLocks noGrp="1"/>
           </p:cNvSpPr>
@@ -723,19 +742,19 @@
           <a:p>
             <a:r>
               <a:rPr lang="fr-FR" b="1" dirty="0"/>
-              <a:t>6:30 - 7:15</a:t>
+              <a:t>5:45 - 6:30</a:t>
             </a:r>
           </a:p>
           <a:p>
             <a:r>
               <a:rPr lang="fr-FR" dirty="0"/>
-              <a:t>Les prochaines etapes. Premiere piste : enrichir encore les faux cas, par exemple en modifiant le texte avec des Transformers ou LLM, ou des outils comme RadGraph.</a:t>
+              <a:t>Les matrices de confusion racontent la meme histoire visuellement : en phase 2, tres peu de vrais positifs sont rates (0.10 de faux negatifs contre 0.21 en phase 1).</a:t>
             </a:r>
           </a:p>
           <a:p>
             <a:r>
               <a:rPr lang="fr-FR" dirty="0"/>
-              <a:t>Seconde piste : rendre l'outil plus intuitif, avec une carte d'attention type Grad-CAM qui surligne les regions decisives, ou un RAG medical.</a:t>
+              <a:t>C'est cette reduction des erreurs, dans les deux sens, qui justifie le choix de l'attention croisee comme modele retenu pour le projet.</a:t>
             </a:r>
           </a:p>
           <a:p>
@@ -745,7 +764,13 @@
       </p:sp>
       <p:sp>
         <p:nvSpPr>
-          <p:cNvPr id="4" name="Slide Number Placeholder 3"/>
+          <p:cNvPr id="4" name="Slide Number Placeholder 3">
+            <a:extLst>
+              <a:ext uri="{FF2B5EF4-FFF2-40B4-BE49-F238E27FC236}">
+                <a16:creationId xmlns:a16="http://schemas.microsoft.com/office/drawing/2014/main" id="{51DEFDAD-1419-9A2F-F6CF-2367641E62A9}"/>
+              </a:ext>
+            </a:extLst>
+          </p:cNvPr>
           <p:cNvSpPr>
             <a:spLocks noGrp="1"/>
           </p:cNvSpPr>
@@ -769,7 +794,7 @@
     </p:spTree>
     <p:extLst>
       <p:ext uri="{BB962C8B-B14F-4D97-AF65-F5344CB8AC3E}">
-        <p14:creationId xmlns:p14="http://schemas.microsoft.com/office/powerpoint/2010/main" val="1024086991"/>
+        <p14:creationId xmlns:p14="http://schemas.microsoft.com/office/powerpoint/2010/main" val="639825025"/>
       </p:ext>
     </p:extLst>
   </p:cSld>
@@ -832,13 +857,19 @@
           <a:p>
             <a:r>
               <a:rPr lang="fr-FR" b="1" dirty="0"/>
-              <a:t>7:15 - 7:30</a:t>
+              <a:t>6:30 - 7:15</a:t>
             </a:r>
           </a:p>
           <a:p>
             <a:r>
               <a:rPr lang="fr-FR" dirty="0"/>
-              <a:t>Annexe disponible si des questions portent sur les sources des donnees, le modele pre-entraine, ou la conformite RGPD - pas besoin de la commenter en detail a l'oral, sauf si le temps le permet.</a:t>
+              <a:t>Les prochaines etapes. Premiere piste : enrichir encore les faux cas, par exemple en modifiant le texte avec des Transformers ou LLM, ou des outils comme RadGraph.</a:t>
+            </a:r>
+          </a:p>
+          <a:p>
+            <a:r>
+              <a:rPr lang="fr-FR" dirty="0"/>
+              <a:t>Seconde piste : rendre l'outil plus intuitif, avec une carte d'attention type Grad-CAM qui surligne les regions decisives, ou un RAG medical.</a:t>
             </a:r>
           </a:p>
           <a:p>
@@ -883,6 +914,109 @@
 </file>
 
 <file path=ppt/notesSlides/notesSlide12.xml><?xml version="1.0" encoding="utf-8"?>
+<p:notes xmlns:a="http://schemas.openxmlformats.org/drawingml/2006/main" xmlns:r="http://schemas.openxmlformats.org/officeDocument/2006/relationships" xmlns:p="http://schemas.openxmlformats.org/presentationml/2006/main">
+  <p:cSld>
+    <p:spTree>
+      <p:nvGrpSpPr>
+        <p:cNvPr id="1" name=""/>
+        <p:cNvGrpSpPr/>
+        <p:nvPr/>
+      </p:nvGrpSpPr>
+      <p:grpSpPr>
+        <a:xfrm>
+          <a:off x="0" y="0"/>
+          <a:ext cx="0" cy="0"/>
+          <a:chOff x="0" y="0"/>
+          <a:chExt cx="0" cy="0"/>
+        </a:xfrm>
+      </p:grpSpPr>
+      <p:sp>
+        <p:nvSpPr>
+          <p:cNvPr id="2" name="Slide Image Placeholder 1"/>
+          <p:cNvSpPr>
+            <a:spLocks noGrp="1" noRot="1" noChangeAspect="1"/>
+          </p:cNvSpPr>
+          <p:nvPr>
+            <p:ph type="sldImg"/>
+          </p:nvPr>
+        </p:nvSpPr>
+        <p:spPr/>
+        <p:txBody>
+          <a:bodyPr/>
+          <a:lstStyle/>
+          <a:p>
+            <a:endParaRPr lang="fr-FR"/>
+          </a:p>
+        </p:txBody>
+      </p:sp>
+      <p:sp>
+        <p:nvSpPr>
+          <p:cNvPr id="3" name="Notes Placeholder 2"/>
+          <p:cNvSpPr>
+            <a:spLocks noGrp="1"/>
+          </p:cNvSpPr>
+          <p:nvPr>
+            <p:ph type="body" idx="1"/>
+          </p:nvPr>
+        </p:nvSpPr>
+        <p:spPr/>
+        <p:txBody>
+          <a:bodyPr/>
+          <a:lstStyle/>
+          <a:p>
+            <a:r>
+              <a:rPr lang="fr-FR" b="1" dirty="0"/>
+              <a:t>7:15 - 7:30</a:t>
+            </a:r>
+          </a:p>
+          <a:p>
+            <a:r>
+              <a:rPr lang="fr-FR" dirty="0"/>
+              <a:t>Annexe disponible si des questions portent sur les sources des donnees, le modele pre-entraine, ou la conformite RGPD - pas besoin de la commenter en detail a l'oral, sauf si le temps le permet.</a:t>
+            </a:r>
+          </a:p>
+          <a:p>
+            <a:endParaRPr lang="fr-FR" dirty="0"/>
+          </a:p>
+        </p:txBody>
+      </p:sp>
+      <p:sp>
+        <p:nvSpPr>
+          <p:cNvPr id="4" name="Slide Number Placeholder 3"/>
+          <p:cNvSpPr>
+            <a:spLocks noGrp="1"/>
+          </p:cNvSpPr>
+          <p:nvPr>
+            <p:ph type="sldNum" sz="quarter" idx="10"/>
+          </p:nvPr>
+        </p:nvSpPr>
+        <p:spPr/>
+        <p:txBody>
+          <a:bodyPr/>
+          <a:lstStyle/>
+          <a:p>
+            <a:fld id="{F7021451-1387-4CA6-816F-3879F97B5CBC}" type="slidenum">
+              <a:rPr lang="en-US"/>
+              <a:t>12</a:t>
+            </a:fld>
+            <a:endParaRPr lang="en-US"/>
+          </a:p>
+        </p:txBody>
+      </p:sp>
+    </p:spTree>
+    <p:extLst>
+      <p:ext uri="{BB962C8B-B14F-4D97-AF65-F5344CB8AC3E}">
+        <p14:creationId xmlns:p14="http://schemas.microsoft.com/office/powerpoint/2010/main" val="1024086991"/>
+      </p:ext>
+    </p:extLst>
+  </p:cSld>
+  <p:clrMapOvr>
+    <a:masterClrMapping/>
+  </p:clrMapOvr>
+</p:notes>
+</file>
+
+<file path=ppt/notesSlides/notesSlide13.xml><?xml version="1.0" encoding="utf-8"?>
 <p:notes xmlns:a="http://schemas.openxmlformats.org/drawingml/2006/main" xmlns:r="http://schemas.openxmlformats.org/officeDocument/2006/relationships" xmlns:p="http://schemas.openxmlformats.org/presentationml/2006/main">
   <p:cSld>
     <p:spTree>
@@ -996,7 +1130,7 @@
           <a:p>
             <a:fld id="{F7021451-1387-4CA6-816F-3879F97B5CBC}" type="slidenum">
               <a:rPr lang="en-US"/>
-              <a:t>12</a:t>
+              <a:t>13</a:t>
             </a:fld>
             <a:endParaRPr lang="en-US"/>
           </a:p>
@@ -1583,13 +1717,6 @@
           </p:nvPr>
         </p:nvSpPr>
         <p:spPr/>
-        <p:txBody>
-          <a:bodyPr/>
-          <a:lstStyle/>
-          <a:p>
-            <a:endParaRPr lang="fr-FR"/>
-          </a:p>
-        </p:txBody>
       </p:sp>
       <p:sp>
         <p:nvSpPr>
@@ -1606,25 +1733,7 @@
           <a:bodyPr/>
           <a:lstStyle/>
           <a:p>
-            <a:r>
-              <a:rPr lang="fr-FR" b="1" dirty="0"/>
-              <a:t>4:00 - 4:45</a:t>
-            </a:r>
-          </a:p>
-          <a:p>
-            <a:r>
-              <a:rPr lang="fr-FR" dirty="0"/>
-              <a:t>Le modele utilise : BioViL-T, specialise pour la radiographie thoracique et ses comptes rendus, plutot qu'un modele medical generaliste.</a:t>
-            </a:r>
-          </a:p>
-          <a:p>
-            <a:r>
-              <a:rPr lang="fr-FR" dirty="0"/>
-              <a:t>Deux encodeurs pre-entraines ensemble par apprentissage contrastif image-texte. Deux phases de lecture : Approche 1, comparer les resumes globaux (similarite) ; Approche 2, faire dialoguer regions et mots (attention croisee).</a:t>
-            </a:r>
-          </a:p>
-          <a:p>
-            <a:endParaRPr lang="fr-FR" dirty="0"/>
+            <a:endParaRPr lang="en-US" dirty="0"/>
           </a:p>
         </p:txBody>
       </p:sp>
@@ -1665,6 +1774,115 @@
 </file>
 
 <file path=ppt/notesSlides/notesSlide8.xml><?xml version="1.0" encoding="utf-8"?>
+<p:notes xmlns:a="http://schemas.openxmlformats.org/drawingml/2006/main" xmlns:r="http://schemas.openxmlformats.org/officeDocument/2006/relationships" xmlns:p="http://schemas.openxmlformats.org/presentationml/2006/main">
+  <p:cSld>
+    <p:spTree>
+      <p:nvGrpSpPr>
+        <p:cNvPr id="1" name=""/>
+        <p:cNvGrpSpPr/>
+        <p:nvPr/>
+      </p:nvGrpSpPr>
+      <p:grpSpPr>
+        <a:xfrm>
+          <a:off x="0" y="0"/>
+          <a:ext cx="0" cy="0"/>
+          <a:chOff x="0" y="0"/>
+          <a:chExt cx="0" cy="0"/>
+        </a:xfrm>
+      </p:grpSpPr>
+      <p:sp>
+        <p:nvSpPr>
+          <p:cNvPr id="2" name="Slide Image Placeholder 1"/>
+          <p:cNvSpPr>
+            <a:spLocks noGrp="1" noRot="1" noChangeAspect="1"/>
+          </p:cNvSpPr>
+          <p:nvPr>
+            <p:ph type="sldImg"/>
+          </p:nvPr>
+        </p:nvSpPr>
+        <p:spPr/>
+        <p:txBody>
+          <a:bodyPr/>
+          <a:lstStyle/>
+          <a:p>
+            <a:endParaRPr lang="fr-FR"/>
+          </a:p>
+        </p:txBody>
+      </p:sp>
+      <p:sp>
+        <p:nvSpPr>
+          <p:cNvPr id="3" name="Notes Placeholder 2"/>
+          <p:cNvSpPr>
+            <a:spLocks noGrp="1"/>
+          </p:cNvSpPr>
+          <p:nvPr>
+            <p:ph type="body" idx="1"/>
+          </p:nvPr>
+        </p:nvSpPr>
+        <p:spPr/>
+        <p:txBody>
+          <a:bodyPr/>
+          <a:lstStyle/>
+          <a:p>
+            <a:r>
+              <a:rPr lang="fr-FR" b="1" dirty="0"/>
+              <a:t>4:00 - 4:45</a:t>
+            </a:r>
+          </a:p>
+          <a:p>
+            <a:r>
+              <a:rPr lang="fr-FR" dirty="0"/>
+              <a:t>Le modele utilise : BioViL-T, specialise pour la radiographie thoracique et ses comptes rendus, plutot qu'un modele medical generaliste.</a:t>
+            </a:r>
+          </a:p>
+          <a:p>
+            <a:r>
+              <a:rPr lang="fr-FR" dirty="0"/>
+              <a:t>Deux encodeurs pre-entraines ensemble par apprentissage contrastif image-texte. Deux phases de lecture : Approche 1, comparer les resumes globaux (similarite) ; Approche 2, faire dialoguer regions et mots (attention croisee).</a:t>
+            </a:r>
+          </a:p>
+          <a:p>
+            <a:endParaRPr lang="fr-FR" dirty="0"/>
+          </a:p>
+        </p:txBody>
+      </p:sp>
+      <p:sp>
+        <p:nvSpPr>
+          <p:cNvPr id="4" name="Slide Number Placeholder 3"/>
+          <p:cNvSpPr>
+            <a:spLocks noGrp="1"/>
+          </p:cNvSpPr>
+          <p:nvPr>
+            <p:ph type="sldNum" sz="quarter" idx="10"/>
+          </p:nvPr>
+        </p:nvSpPr>
+        <p:spPr/>
+        <p:txBody>
+          <a:bodyPr/>
+          <a:lstStyle/>
+          <a:p>
+            <a:fld id="{F7021451-1387-4CA6-816F-3879F97B5CBC}" type="slidenum">
+              <a:rPr lang="en-US"/>
+              <a:t>8</a:t>
+            </a:fld>
+            <a:endParaRPr lang="en-US"/>
+          </a:p>
+        </p:txBody>
+      </p:sp>
+    </p:spTree>
+    <p:extLst>
+      <p:ext uri="{BB962C8B-B14F-4D97-AF65-F5344CB8AC3E}">
+        <p14:creationId xmlns:p14="http://schemas.microsoft.com/office/powerpoint/2010/main" val="1024086991"/>
+      </p:ext>
+    </p:extLst>
+  </p:cSld>
+  <p:clrMapOvr>
+    <a:masterClrMapping/>
+  </p:clrMapOvr>
+</p:notes>
+</file>
+
+<file path=ppt/notesSlides/notesSlide9.xml><?xml version="1.0" encoding="utf-8"?>
 <p:notes xmlns:a="http://schemas.openxmlformats.org/drawingml/2006/main" xmlns:r="http://schemas.openxmlformats.org/officeDocument/2006/relationships" xmlns:p="http://schemas.openxmlformats.org/presentationml/2006/main">
   <p:cSld>
     <p:spTree>
@@ -1778,7 +1996,7 @@
           <a:p>
             <a:fld id="{F7021451-1387-4CA6-816F-3879F97B5CBC}" type="slidenum">
               <a:rPr lang="en-US"/>
-              <a:t>8</a:t>
+              <a:t>9</a:t>
             </a:fld>
             <a:endParaRPr lang="en-US"/>
           </a:p>
@@ -1788,139 +2006,6 @@
     <p:extLst>
       <p:ext uri="{BB962C8B-B14F-4D97-AF65-F5344CB8AC3E}">
         <p14:creationId xmlns:p14="http://schemas.microsoft.com/office/powerpoint/2010/main" val="206535955"/>
-      </p:ext>
-    </p:extLst>
-  </p:cSld>
-  <p:clrMapOvr>
-    <a:masterClrMapping/>
-  </p:clrMapOvr>
-</p:notes>
-</file>
-
-<file path=ppt/notesSlides/notesSlide9.xml><?xml version="1.0" encoding="utf-8"?>
-<p:notes xmlns:a="http://schemas.openxmlformats.org/drawingml/2006/main" xmlns:r="http://schemas.openxmlformats.org/officeDocument/2006/relationships" xmlns:p="http://schemas.openxmlformats.org/presentationml/2006/main">
-  <p:cSld>
-    <p:spTree>
-      <p:nvGrpSpPr>
-        <p:cNvPr id="1" name="">
-          <a:extLst>
-            <a:ext uri="{FF2B5EF4-FFF2-40B4-BE49-F238E27FC236}">
-              <a16:creationId xmlns:a16="http://schemas.microsoft.com/office/drawing/2014/main" id="{D39B2396-5488-9F4F-8893-CD4766E0D863}"/>
-            </a:ext>
-          </a:extLst>
-        </p:cNvPr>
-        <p:cNvGrpSpPr/>
-        <p:nvPr/>
-      </p:nvGrpSpPr>
-      <p:grpSpPr>
-        <a:xfrm>
-          <a:off x="0" y="0"/>
-          <a:ext cx="0" cy="0"/>
-          <a:chOff x="0" y="0"/>
-          <a:chExt cx="0" cy="0"/>
-        </a:xfrm>
-      </p:grpSpPr>
-      <p:sp>
-        <p:nvSpPr>
-          <p:cNvPr id="2" name="Slide Image Placeholder 1">
-            <a:extLst>
-              <a:ext uri="{FF2B5EF4-FFF2-40B4-BE49-F238E27FC236}">
-                <a16:creationId xmlns:a16="http://schemas.microsoft.com/office/drawing/2014/main" id="{5AF860BD-C3D4-44B6-8907-3CB003688ADC}"/>
-              </a:ext>
-            </a:extLst>
-          </p:cNvPr>
-          <p:cNvSpPr>
-            <a:spLocks noGrp="1" noRot="1" noChangeAspect="1"/>
-          </p:cNvSpPr>
-          <p:nvPr>
-            <p:ph type="sldImg"/>
-          </p:nvPr>
-        </p:nvSpPr>
-        <p:spPr/>
-        <p:txBody>
-          <a:bodyPr/>
-          <a:lstStyle/>
-          <a:p>
-            <a:endParaRPr lang="fr-FR"/>
-          </a:p>
-        </p:txBody>
-      </p:sp>
-      <p:sp>
-        <p:nvSpPr>
-          <p:cNvPr id="3" name="Notes Placeholder 2">
-            <a:extLst>
-              <a:ext uri="{FF2B5EF4-FFF2-40B4-BE49-F238E27FC236}">
-                <a16:creationId xmlns:a16="http://schemas.microsoft.com/office/drawing/2014/main" id="{18AC209A-05DC-98A5-2678-2FF4B78731A9}"/>
-              </a:ext>
-            </a:extLst>
-          </p:cNvPr>
-          <p:cNvSpPr>
-            <a:spLocks noGrp="1"/>
-          </p:cNvSpPr>
-          <p:nvPr>
-            <p:ph type="body" idx="1"/>
-          </p:nvPr>
-        </p:nvSpPr>
-        <p:spPr/>
-        <p:txBody>
-          <a:bodyPr/>
-          <a:lstStyle/>
-          <a:p>
-            <a:r>
-              <a:rPr lang="fr-FR" b="1" dirty="0"/>
-              <a:t>5:45 - 6:30</a:t>
-            </a:r>
-          </a:p>
-          <a:p>
-            <a:r>
-              <a:rPr lang="fr-FR" dirty="0"/>
-              <a:t>Les matrices de confusion racontent la meme histoire visuellement : en phase 2, tres peu de vrais positifs sont rates (0.10 de faux negatifs contre 0.21 en phase 1).</a:t>
-            </a:r>
-          </a:p>
-          <a:p>
-            <a:r>
-              <a:rPr lang="fr-FR" dirty="0"/>
-              <a:t>C'est cette reduction des erreurs, dans les deux sens, qui justifie le choix de l'attention croisee comme modele retenu pour le projet.</a:t>
-            </a:r>
-          </a:p>
-          <a:p>
-            <a:endParaRPr lang="fr-FR" dirty="0"/>
-          </a:p>
-        </p:txBody>
-      </p:sp>
-      <p:sp>
-        <p:nvSpPr>
-          <p:cNvPr id="4" name="Slide Number Placeholder 3">
-            <a:extLst>
-              <a:ext uri="{FF2B5EF4-FFF2-40B4-BE49-F238E27FC236}">
-                <a16:creationId xmlns:a16="http://schemas.microsoft.com/office/drawing/2014/main" id="{51DEFDAD-1419-9A2F-F6CF-2367641E62A9}"/>
-              </a:ext>
-            </a:extLst>
-          </p:cNvPr>
-          <p:cNvSpPr>
-            <a:spLocks noGrp="1"/>
-          </p:cNvSpPr>
-          <p:nvPr>
-            <p:ph type="sldNum" sz="quarter" idx="10"/>
-          </p:nvPr>
-        </p:nvSpPr>
-        <p:spPr/>
-        <p:txBody>
-          <a:bodyPr/>
-          <a:lstStyle/>
-          <a:p>
-            <a:fld id="{F7021451-1387-4CA6-816F-3879F97B5CBC}" type="slidenum">
-              <a:rPr lang="en-US"/>
-              <a:t>9</a:t>
-            </a:fld>
-            <a:endParaRPr lang="en-US"/>
-          </a:p>
-        </p:txBody>
-      </p:sp>
-    </p:spTree>
-    <p:extLst>
-      <p:ext uri="{BB962C8B-B14F-4D97-AF65-F5344CB8AC3E}">
-        <p14:creationId xmlns:p14="http://schemas.microsoft.com/office/powerpoint/2010/main" val="639825025"/>
       </p:ext>
     </p:extLst>
   </p:cSld>
@@ -1972,7 +2057,7 @@
           </a:prstGeom>
           <a:extLst>
             <a:ext uri="{C572A759-6A51-4108-AA02-DFA0A04FC94B}">
-              <ma14:wrappingTextBoxFlag xmlns:ma14="http://schemas.microsoft.com/office/mac/drawingml/2011/main" xmlns="" val="0"/>
+              <ma14:wrappingTextBoxFlag xmlns="" xmlns:ma14="http://schemas.microsoft.com/office/mac/drawingml/2011/main" val="0"/>
             </a:ext>
           </a:extLst>
         </p:spPr>
@@ -2050,7 +2135,7 @@
           </a:prstGeom>
           <a:extLst>
             <a:ext uri="{C572A759-6A51-4108-AA02-DFA0A04FC94B}">
-              <ma14:wrappingTextBoxFlag xmlns:ma14="http://schemas.microsoft.com/office/mac/drawingml/2011/main" xmlns="" val="0"/>
+              <ma14:wrappingTextBoxFlag xmlns="" xmlns:ma14="http://schemas.microsoft.com/office/mac/drawingml/2011/main" val="0"/>
             </a:ext>
           </a:extLst>
         </p:spPr>
@@ -2634,6 +2719,390 @@
 
 <file path=ppt/slides/slide10.xml><?xml version="1.0" encoding="utf-8"?>
 <p:sld xmlns:a="http://schemas.openxmlformats.org/drawingml/2006/main" xmlns:r="http://schemas.openxmlformats.org/officeDocument/2006/relationships" xmlns:p="http://schemas.openxmlformats.org/presentationml/2006/main">
+  <p:cSld>
+    <p:spTree>
+      <p:nvGrpSpPr>
+        <p:cNvPr id="1" name="">
+          <a:extLst>
+            <a:ext uri="{FF2B5EF4-FFF2-40B4-BE49-F238E27FC236}">
+              <a16:creationId xmlns:a16="http://schemas.microsoft.com/office/drawing/2014/main" id="{EA162FD1-BD63-AE73-F8C5-B545DA785195}"/>
+            </a:ext>
+          </a:extLst>
+        </p:cNvPr>
+        <p:cNvGrpSpPr/>
+        <p:nvPr/>
+      </p:nvGrpSpPr>
+      <p:grpSpPr>
+        <a:xfrm>
+          <a:off x="0" y="0"/>
+          <a:ext cx="0" cy="0"/>
+          <a:chOff x="0" y="0"/>
+          <a:chExt cx="0" cy="0"/>
+        </a:xfrm>
+      </p:grpSpPr>
+      <p:sp>
+        <p:nvSpPr>
+          <p:cNvPr id="2" name="Shape 0">
+            <a:extLst>
+              <a:ext uri="{FF2B5EF4-FFF2-40B4-BE49-F238E27FC236}">
+                <a16:creationId xmlns:a16="http://schemas.microsoft.com/office/drawing/2014/main" id="{30540348-C0CF-1E07-7141-23FB128D2A42}"/>
+              </a:ext>
+            </a:extLst>
+          </p:cNvPr>
+          <p:cNvSpPr/>
+          <p:nvPr/>
+        </p:nvSpPr>
+        <p:spPr>
+          <a:xfrm>
+            <a:off x="566928" y="457200"/>
+            <a:ext cx="658368" cy="658368"/>
+          </a:xfrm>
+          <a:prstGeom prst="ellipse">
+            <a:avLst/>
+          </a:prstGeom>
+          <a:solidFill>
+            <a:srgbClr val="1FA8B8"/>
+          </a:solidFill>
+          <a:ln/>
+        </p:spPr>
+        <p:txBody>
+          <a:bodyPr/>
+          <a:lstStyle/>
+          <a:p>
+            <a:endParaRPr lang="fr-FR" noProof="0" dirty="0"/>
+          </a:p>
+        </p:txBody>
+      </p:sp>
+      <p:pic>
+        <p:nvPicPr>
+          <p:cNvPr id="3" name="Image 0" descr="preencoded.png">
+            <a:extLst>
+              <a:ext uri="{FF2B5EF4-FFF2-40B4-BE49-F238E27FC236}">
+                <a16:creationId xmlns:a16="http://schemas.microsoft.com/office/drawing/2014/main" id="{F3ADC3F1-8C17-5F39-0FE5-46BFE49A73B6}"/>
+              </a:ext>
+            </a:extLst>
+          </p:cNvPr>
+          <p:cNvPicPr>
+            <a:picLocks noChangeAspect="1"/>
+          </p:cNvPicPr>
+          <p:nvPr/>
+        </p:nvPicPr>
+        <p:blipFill>
+          <a:blip r:embed="rId3"/>
+          <a:stretch>
+            <a:fillRect/>
+          </a:stretch>
+        </p:blipFill>
+        <p:spPr>
+          <a:xfrm>
+            <a:off x="731520" y="621792"/>
+            <a:ext cx="329184" cy="329184"/>
+          </a:xfrm>
+          <a:prstGeom prst="rect">
+            <a:avLst/>
+          </a:prstGeom>
+        </p:spPr>
+      </p:pic>
+      <p:sp>
+        <p:nvSpPr>
+          <p:cNvPr id="4" name="Text 1">
+            <a:extLst>
+              <a:ext uri="{FF2B5EF4-FFF2-40B4-BE49-F238E27FC236}">
+                <a16:creationId xmlns:a16="http://schemas.microsoft.com/office/drawing/2014/main" id="{B74649CF-524E-1554-2185-05874BAF25DB}"/>
+              </a:ext>
+            </a:extLst>
+          </p:cNvPr>
+          <p:cNvSpPr/>
+          <p:nvPr/>
+        </p:nvSpPr>
+        <p:spPr>
+          <a:xfrm>
+            <a:off x="1417320" y="420624"/>
+            <a:ext cx="10241280" cy="274320"/>
+          </a:xfrm>
+          <a:prstGeom prst="rect">
+            <a:avLst/>
+          </a:prstGeom>
+          <a:noFill/>
+          <a:ln/>
+        </p:spPr>
+        <p:txBody>
+          <a:bodyPr wrap="square" lIns="0" tIns="0" rIns="0" bIns="0" rtlCol="0" anchor="ctr"/>
+          <a:lstStyle/>
+          <a:p>
+            <a:pPr marL="0" indent="0">
+              <a:buNone/>
+            </a:pPr>
+            <a:r>
+              <a:rPr lang="fr-FR" sz="1100" b="1" kern="0" spc="200" noProof="0" dirty="0">
+                <a:solidFill>
+                  <a:srgbClr val="12798A"/>
+                </a:solidFill>
+                <a:latin typeface="Calibri" pitchFamily="34" charset="0"/>
+                <a:ea typeface="Calibri" pitchFamily="34" charset="-122"/>
+                <a:cs typeface="Calibri" pitchFamily="34" charset="-120"/>
+              </a:rPr>
+              <a:t>SECTION 05 - CE QUE RACONTENT LES CHIFFRES</a:t>
+            </a:r>
+            <a:endParaRPr lang="fr-FR" sz="1100" noProof="0" dirty="0"/>
+          </a:p>
+        </p:txBody>
+      </p:sp>
+      <p:sp>
+        <p:nvSpPr>
+          <p:cNvPr id="5" name="Text 2">
+            <a:extLst>
+              <a:ext uri="{FF2B5EF4-FFF2-40B4-BE49-F238E27FC236}">
+                <a16:creationId xmlns:a16="http://schemas.microsoft.com/office/drawing/2014/main" id="{3985DFBF-F171-091E-AD37-EA7008BA044D}"/>
+              </a:ext>
+            </a:extLst>
+          </p:cNvPr>
+          <p:cNvSpPr/>
+          <p:nvPr/>
+        </p:nvSpPr>
+        <p:spPr>
+          <a:xfrm>
+            <a:off x="1417320" y="658368"/>
+            <a:ext cx="10241280" cy="566928"/>
+          </a:xfrm>
+          <a:prstGeom prst="rect">
+            <a:avLst/>
+          </a:prstGeom>
+          <a:noFill/>
+          <a:ln/>
+        </p:spPr>
+        <p:txBody>
+          <a:bodyPr wrap="square" lIns="0" tIns="0" rIns="0" bIns="0" rtlCol="0" anchor="ctr"/>
+          <a:lstStyle/>
+          <a:p>
+            <a:pPr marL="0" indent="0">
+              <a:buNone/>
+            </a:pPr>
+            <a:r>
+              <a:rPr lang="fr-FR" sz="2700" b="1" noProof="0" dirty="0">
+                <a:solidFill>
+                  <a:srgbClr val="16243F"/>
+                </a:solidFill>
+                <a:latin typeface="Cambria" pitchFamily="34" charset="0"/>
+                <a:ea typeface="Cambria" pitchFamily="34" charset="-122"/>
+              </a:rPr>
+              <a:t>Matrices de confusion</a:t>
+            </a:r>
+            <a:endParaRPr lang="fr-FR" sz="2700" noProof="0" dirty="0"/>
+          </a:p>
+        </p:txBody>
+      </p:sp>
+      <p:sp>
+        <p:nvSpPr>
+          <p:cNvPr id="6" name="Text 3">
+            <a:extLst>
+              <a:ext uri="{FF2B5EF4-FFF2-40B4-BE49-F238E27FC236}">
+                <a16:creationId xmlns:a16="http://schemas.microsoft.com/office/drawing/2014/main" id="{29213612-5A48-59B7-BD43-E07D3A582AC7}"/>
+              </a:ext>
+            </a:extLst>
+          </p:cNvPr>
+          <p:cNvSpPr/>
+          <p:nvPr/>
+        </p:nvSpPr>
+        <p:spPr>
+          <a:xfrm>
+            <a:off x="2394483" y="1600200"/>
+            <a:ext cx="2147217" cy="365760"/>
+          </a:xfrm>
+          <a:prstGeom prst="rect">
+            <a:avLst/>
+          </a:prstGeom>
+          <a:noFill/>
+          <a:ln/>
+        </p:spPr>
+        <p:txBody>
+          <a:bodyPr wrap="square" lIns="0" tIns="0" rIns="0" bIns="0" rtlCol="0" anchor="ctr"/>
+          <a:lstStyle/>
+          <a:p>
+            <a:r>
+              <a:rPr lang="fr-FR" sz="1600" b="1">
+                <a:solidFill>
+                  <a:srgbClr val="16243F"/>
+                </a:solidFill>
+                <a:latin typeface="Cambria"/>
+                <a:ea typeface="Cambria"/>
+              </a:rPr>
+              <a:t>La similarité</a:t>
+            </a:r>
+            <a:endParaRPr lang="fr-FR" sz="1600" noProof="0" dirty="0"/>
+          </a:p>
+        </p:txBody>
+      </p:sp>
+      <p:sp>
+        <p:nvSpPr>
+          <p:cNvPr id="25" name="Slide Number Placeholder 0">
+            <a:extLst>
+              <a:ext uri="{FF2B5EF4-FFF2-40B4-BE49-F238E27FC236}">
+                <a16:creationId xmlns:a16="http://schemas.microsoft.com/office/drawing/2014/main" id="{A20053B0-029D-DAAB-9131-2B7ECA3C456A}"/>
+              </a:ext>
+            </a:extLst>
+          </p:cNvPr>
+          <p:cNvSpPr>
+            <a:spLocks noGrp="1"/>
+          </p:cNvSpPr>
+          <p:nvPr>
+            <p:ph type="sldNum" sz="quarter" idx="4294967295"/>
+          </p:nvPr>
+        </p:nvSpPr>
+        <p:spPr>
+          <a:xfrm>
+            <a:off x="11430000" y="6455664"/>
+            <a:ext cx="640080" cy="274320"/>
+          </a:xfrm>
+          <a:prstGeom prst="rect">
+            <a:avLst/>
+          </a:prstGeom>
+          <a:extLst>
+            <a:ext uri="{C572A759-6A51-4108-AA02-DFA0A04FC94B}">
+              <ma14:wrappingTextBoxFlag xmlns="" xmlns:ma14="http://schemas.microsoft.com/office/mac/drawingml/2011/main" val="0"/>
+            </a:ext>
+          </a:extLst>
+        </p:spPr>
+        <p:txBody>
+          <a:bodyPr/>
+          <a:lstStyle>
+            <a:lvl1pPr>
+              <a:defRPr sz="1000">
+                <a:solidFill>
+                  <a:srgbClr val="5E6E7E"/>
+                </a:solidFill>
+                <a:latin typeface="Calibri"/>
+                <a:ea typeface="Calibri"/>
+                <a:cs typeface="Calibri"/>
+              </a:defRPr>
+            </a:lvl1pPr>
+          </a:lstStyle>
+          <a:p>
+            <a:pPr algn="r"/>
+            <a:fld id="{F7021451-1387-4CA6-816F-3879F97B5CBC}" type="slidenum">
+              <a:rPr lang="fr-FR" b="0" noProof="0" smtClean="0"/>
+              <a:t>10</a:t>
+            </a:fld>
+            <a:endParaRPr lang="fr-FR" noProof="0" dirty="0"/>
+          </a:p>
+        </p:txBody>
+      </p:sp>
+      <p:sp>
+        <p:nvSpPr>
+          <p:cNvPr id="7" name="Text 3">
+            <a:extLst>
+              <a:ext uri="{FF2B5EF4-FFF2-40B4-BE49-F238E27FC236}">
+                <a16:creationId xmlns:a16="http://schemas.microsoft.com/office/drawing/2014/main" id="{A018F4DE-35D8-F33F-5DEC-5623FC02AF6C}"/>
+              </a:ext>
+            </a:extLst>
+          </p:cNvPr>
+          <p:cNvSpPr/>
+          <p:nvPr/>
+        </p:nvSpPr>
+        <p:spPr>
+          <a:xfrm>
+            <a:off x="8066117" y="1600200"/>
+            <a:ext cx="1627728" cy="365760"/>
+          </a:xfrm>
+          <a:prstGeom prst="rect">
+            <a:avLst/>
+          </a:prstGeom>
+          <a:noFill/>
+          <a:ln/>
+        </p:spPr>
+        <p:txBody>
+          <a:bodyPr wrap="square" lIns="0" tIns="0" rIns="0" bIns="0" rtlCol="0" anchor="ctr"/>
+          <a:lstStyle/>
+          <a:p>
+            <a:r>
+              <a:rPr lang="fr-FR" sz="1600" b="1">
+                <a:solidFill>
+                  <a:srgbClr val="16243F"/>
+                </a:solidFill>
+                <a:latin typeface="Cambria"/>
+                <a:ea typeface="Cambria"/>
+              </a:rPr>
+              <a:t>Cross Attention</a:t>
+            </a:r>
+            <a:endParaRPr lang="fr-FR" sz="1600" noProof="0" dirty="0"/>
+          </a:p>
+        </p:txBody>
+      </p:sp>
+      <p:pic>
+        <p:nvPicPr>
+          <p:cNvPr id="8" name="Image 7" descr="Une image contenant texte, capture d’écran, Police, diagramme  Le contenu généré par l’IA peut être incorrect.">
+            <a:extLst>
+              <a:ext uri="{FF2B5EF4-FFF2-40B4-BE49-F238E27FC236}">
+                <a16:creationId xmlns:a16="http://schemas.microsoft.com/office/drawing/2014/main" id="{8931718B-D51E-AD6A-231B-854AF1B76B72}"/>
+              </a:ext>
+            </a:extLst>
+          </p:cNvPr>
+          <p:cNvPicPr>
+            <a:picLocks noChangeAspect="1"/>
+          </p:cNvPicPr>
+          <p:nvPr/>
+        </p:nvPicPr>
+        <p:blipFill>
+          <a:blip r:embed="rId4"/>
+          <a:stretch>
+            <a:fillRect/>
+          </a:stretch>
+        </p:blipFill>
+        <p:spPr>
+          <a:xfrm>
+            <a:off x="1088988" y="2062743"/>
+            <a:ext cx="3908734" cy="3829050"/>
+          </a:xfrm>
+          <a:prstGeom prst="rect">
+            <a:avLst/>
+          </a:prstGeom>
+        </p:spPr>
+      </p:pic>
+      <p:pic>
+        <p:nvPicPr>
+          <p:cNvPr id="9" name="Image 8" descr="Une image contenant texte, capture d’écran, Police, nombre  Le contenu généré par l’IA peut être incorrect.">
+            <a:extLst>
+              <a:ext uri="{FF2B5EF4-FFF2-40B4-BE49-F238E27FC236}">
+                <a16:creationId xmlns:a16="http://schemas.microsoft.com/office/drawing/2014/main" id="{9245F59E-EA40-E3E2-8B7E-868F32C57DBD}"/>
+              </a:ext>
+            </a:extLst>
+          </p:cNvPr>
+          <p:cNvPicPr>
+            <a:picLocks noChangeAspect="1"/>
+          </p:cNvPicPr>
+          <p:nvPr/>
+        </p:nvPicPr>
+        <p:blipFill>
+          <a:blip r:embed="rId5"/>
+          <a:stretch>
+            <a:fillRect/>
+          </a:stretch>
+        </p:blipFill>
+        <p:spPr>
+          <a:xfrm>
+            <a:off x="6746837" y="2059375"/>
+            <a:ext cx="4255351" cy="3724275"/>
+          </a:xfrm>
+          <a:prstGeom prst="rect">
+            <a:avLst/>
+          </a:prstGeom>
+        </p:spPr>
+      </p:pic>
+    </p:spTree>
+    <p:extLst>
+      <p:ext uri="{BB962C8B-B14F-4D97-AF65-F5344CB8AC3E}">
+        <p14:creationId xmlns:p14="http://schemas.microsoft.com/office/powerpoint/2010/main" val="3567918940"/>
+      </p:ext>
+    </p:extLst>
+  </p:cSld>
+  <p:clrMapOvr>
+    <a:masterClrMapping/>
+  </p:clrMapOvr>
+</p:sld>
+</file>
+
+<file path=ppt/slides/slide11.xml><?xml version="1.0" encoding="utf-8"?>
+<p:sld xmlns:a="http://schemas.openxmlformats.org/drawingml/2006/main" xmlns:r="http://schemas.openxmlformats.org/officeDocument/2006/relationships" xmlns:p="http://schemas.openxmlformats.org/presentationml/2006/main">
   <p:cSld name="Slide 10">
     <p:bg>
       <p:bgPr>
@@ -2985,7 +3454,7 @@
           </a:prstGeom>
           <a:extLst>
             <a:ext uri="{C572A759-6A51-4108-AA02-DFA0A04FC94B}">
-              <ma14:wrappingTextBoxFlag xmlns:ma14="http://schemas.microsoft.com/office/mac/drawingml/2011/main" xmlns="" val="0"/>
+              <ma14:wrappingTextBoxFlag xmlns="" xmlns:ma14="http://schemas.microsoft.com/office/mac/drawingml/2011/main" val="0"/>
             </a:ext>
           </a:extLst>
         </p:spPr>
@@ -3007,7 +3476,7 @@
             <a:pPr algn="r"/>
             <a:fld id="{F7021451-1387-4CA6-816F-3879F97B5CBC}" type="slidenum">
               <a:rPr lang="fr-FR" b="0" noProof="0" smtClean="0"/>
-              <a:t>10</a:t>
+              <a:t>11</a:t>
             </a:fld>
             <a:endParaRPr lang="fr-FR" noProof="0" dirty="0"/>
           </a:p>
@@ -3637,7 +4106,7 @@
 </p:sld>
 </file>
 
-<file path=ppt/slides/slide11.xml><?xml version="1.0" encoding="utf-8"?>
+<file path=ppt/slides/slide12.xml><?xml version="1.0" encoding="utf-8"?>
 <p:sld xmlns:a="http://schemas.openxmlformats.org/drawingml/2006/main" xmlns:r="http://schemas.openxmlformats.org/officeDocument/2006/relationships" xmlns:p="http://schemas.openxmlformats.org/presentationml/2006/main">
   <p:cSld name="Slide 11">
     <p:bg>
@@ -5008,7 +5477,7 @@
           </a:prstGeom>
           <a:extLst>
             <a:ext uri="{C572A759-6A51-4108-AA02-DFA0A04FC94B}">
-              <ma14:wrappingTextBoxFlag xmlns:ma14="http://schemas.microsoft.com/office/mac/drawingml/2011/main" xmlns="" val="0"/>
+              <ma14:wrappingTextBoxFlag xmlns="" xmlns:ma14="http://schemas.microsoft.com/office/mac/drawingml/2011/main" val="0"/>
             </a:ext>
           </a:extLst>
         </p:spPr>
@@ -5030,7 +5499,7 @@
             <a:pPr algn="r"/>
             <a:fld id="{F7021451-1387-4CA6-816F-3879F97B5CBC}" type="slidenum">
               <a:rPr lang="fr-FR" b="0" noProof="0" smtClean="0"/>
-              <a:t>11</a:t>
+              <a:t>12</a:t>
             </a:fld>
             <a:endParaRPr lang="fr-FR" noProof="0" dirty="0"/>
           </a:p>
@@ -5044,7 +5513,7 @@
 </p:sld>
 </file>
 
-<file path=ppt/slides/slide12.xml><?xml version="1.0" encoding="utf-8"?>
+<file path=ppt/slides/slide13.xml><?xml version="1.0" encoding="utf-8"?>
 <p:sld xmlns:a="http://schemas.openxmlformats.org/drawingml/2006/main" xmlns:r="http://schemas.openxmlformats.org/officeDocument/2006/relationships" xmlns:p="http://schemas.openxmlformats.org/presentationml/2006/main">
   <p:cSld>
     <p:bg>
@@ -5169,7 +5638,7 @@
           </a:prstGeom>
           <a:extLst>
             <a:ext uri="{C572A759-6A51-4108-AA02-DFA0A04FC94B}">
-              <ma14:wrappingTextBoxFlag xmlns:ma14="http://schemas.microsoft.com/office/mac/drawingml/2011/main" xmlns="" val="0"/>
+              <ma14:wrappingTextBoxFlag xmlns="" xmlns:ma14="http://schemas.microsoft.com/office/mac/drawingml/2011/main" val="0"/>
             </a:ext>
           </a:extLst>
         </p:spPr>
@@ -5191,7 +5660,7 @@
             <a:pPr algn="r"/>
             <a:fld id="{F7021451-1387-4CA6-816F-3879F97B5CBC}" type="slidenum">
               <a:rPr lang="fr-FR" b="0" noProof="0" smtClean="0"/>
-              <a:t>12</a:t>
+              <a:t>13</a:t>
             </a:fld>
             <a:endParaRPr lang="fr-FR" noProof="0" dirty="0"/>
           </a:p>
@@ -5735,7 +6204,7 @@
           </a:prstGeom>
           <a:extLst>
             <a:ext uri="{C572A759-6A51-4108-AA02-DFA0A04FC94B}">
-              <ma14:wrappingTextBoxFlag xmlns:ma14="http://schemas.microsoft.com/office/mac/drawingml/2011/main" xmlns="" val="0"/>
+              <ma14:wrappingTextBoxFlag xmlns="" xmlns:ma14="http://schemas.microsoft.com/office/mac/drawingml/2011/main" val="0"/>
             </a:ext>
           </a:extLst>
         </p:spPr>
@@ -7106,7 +7575,7 @@
           </a:prstGeom>
           <a:extLst>
             <a:ext uri="{C572A759-6A51-4108-AA02-DFA0A04FC94B}">
-              <ma14:wrappingTextBoxFlag xmlns:ma14="http://schemas.microsoft.com/office/mac/drawingml/2011/main" xmlns="" val="0"/>
+              <ma14:wrappingTextBoxFlag xmlns="" xmlns:ma14="http://schemas.microsoft.com/office/mac/drawingml/2011/main" val="0"/>
             </a:ext>
           </a:extLst>
         </p:spPr>
@@ -8101,7 +8570,7 @@
           </a:prstGeom>
           <a:extLst>
             <a:ext uri="{C572A759-6A51-4108-AA02-DFA0A04FC94B}">
-              <ma14:wrappingTextBoxFlag xmlns:ma14="http://schemas.microsoft.com/office/mac/drawingml/2011/main" xmlns="" val="0"/>
+              <ma14:wrappingTextBoxFlag xmlns="" xmlns:ma14="http://schemas.microsoft.com/office/mac/drawingml/2011/main" val="0"/>
             </a:ext>
           </a:extLst>
         </p:spPr>
@@ -9097,7 +9566,7 @@
           </a:prstGeom>
           <a:extLst>
             <a:ext uri="{C572A759-6A51-4108-AA02-DFA0A04FC94B}">
-              <ma14:wrappingTextBoxFlag xmlns:ma14="http://schemas.microsoft.com/office/mac/drawingml/2011/main" xmlns="" val="0"/>
+              <ma14:wrappingTextBoxFlag xmlns="" xmlns:ma14="http://schemas.microsoft.com/office/mac/drawingml/2011/main" val="0"/>
             </a:ext>
           </a:extLst>
         </p:spPr>
@@ -9164,6 +9633,1626 @@
 </file>
 
 <file path=ppt/slides/slide7.xml><?xml version="1.0" encoding="utf-8"?>
+<p:sld xmlns:a="http://schemas.openxmlformats.org/drawingml/2006/main" xmlns:r="http://schemas.openxmlformats.org/officeDocument/2006/relationships" xmlns:p="http://schemas.openxmlformats.org/presentationml/2006/main">
+  <p:cSld>
+    <p:spTree>
+      <p:nvGrpSpPr>
+        <p:cNvPr id="1" name=""/>
+        <p:cNvGrpSpPr/>
+        <p:nvPr/>
+      </p:nvGrpSpPr>
+      <p:grpSpPr>
+        <a:xfrm>
+          <a:off x="0" y="0"/>
+          <a:ext cx="0" cy="0"/>
+          <a:chOff x="0" y="0"/>
+          <a:chExt cx="0" cy="0"/>
+        </a:xfrm>
+      </p:grpSpPr>
+      <p:sp>
+        <p:nvSpPr>
+          <p:cNvPr id="2" name="Text 0"/>
+          <p:cNvSpPr/>
+          <p:nvPr/>
+        </p:nvSpPr>
+        <p:spPr>
+          <a:xfrm>
+            <a:off x="457200" y="292608"/>
+            <a:ext cx="11247120" cy="548640"/>
+          </a:xfrm>
+          <a:prstGeom prst="rect">
+            <a:avLst/>
+          </a:prstGeom>
+          <a:noFill/>
+          <a:ln/>
+        </p:spPr>
+        <p:txBody>
+          <a:bodyPr wrap="square" lIns="0" tIns="0" rIns="0" bIns="0" rtlCol="0" anchor="ctr"/>
+          <a:lstStyle/>
+          <a:p>
+            <a:pPr marL="0" indent="0" algn="l">
+              <a:buNone/>
+            </a:pPr>
+            <a:r>
+              <a:rPr lang="en-US" sz="2800" b="1" dirty="0">
+                <a:solidFill>
+                  <a:srgbClr val="14264A"/>
+                </a:solidFill>
+                <a:latin typeface="Cambria" pitchFamily="34" charset="0"/>
+                <a:ea typeface="Cambria" pitchFamily="34" charset="-122"/>
+                <a:cs typeface="Cambria" pitchFamily="34" charset="-120"/>
+              </a:rPr>
+              <a:t>Comment le code fabrique les paires incohérentes</a:t>
+            </a:r>
+            <a:endParaRPr lang="en-US" sz="2800" dirty="0"/>
+          </a:p>
+        </p:txBody>
+      </p:sp>
+      <p:sp>
+        <p:nvSpPr>
+          <p:cNvPr id="3" name="Text 1"/>
+          <p:cNvSpPr/>
+          <p:nvPr/>
+        </p:nvSpPr>
+        <p:spPr>
+          <a:xfrm>
+            <a:off x="457200" y="868680"/>
+            <a:ext cx="11247120" cy="320040"/>
+          </a:xfrm>
+          <a:prstGeom prst="rect">
+            <a:avLst/>
+          </a:prstGeom>
+          <a:noFill/>
+          <a:ln/>
+        </p:spPr>
+        <p:txBody>
+          <a:bodyPr wrap="square" lIns="0" tIns="0" rIns="0" bIns="0" rtlCol="0" anchor="ctr"/>
+          <a:lstStyle/>
+          <a:p>
+            <a:pPr marL="0" indent="0" algn="l">
+              <a:buNone/>
+            </a:pPr>
+            <a:r>
+              <a:rPr lang="en-US" sz="1300" i="1" dirty="0">
+                <a:solidFill>
+                  <a:srgbClr val="1C7C8C"/>
+                </a:solidFill>
+                <a:latin typeface="Calibri" pitchFamily="34" charset="0"/>
+                <a:ea typeface="Calibri" pitchFamily="34" charset="-122"/>
+                <a:cs typeface="Calibri" pitchFamily="34" charset="-120"/>
+              </a:rPr>
+              <a:t>Un échange contrôlé de comptes rendus entre patients, sans intelligence artificielle</a:t>
+            </a:r>
+            <a:endParaRPr lang="en-US" sz="1300" dirty="0"/>
+          </a:p>
+        </p:txBody>
+      </p:sp>
+      <p:sp>
+        <p:nvSpPr>
+          <p:cNvPr id="4" name="Shape 2"/>
+          <p:cNvSpPr/>
+          <p:nvPr/>
+        </p:nvSpPr>
+        <p:spPr>
+          <a:xfrm>
+            <a:off x="457200" y="1417320"/>
+            <a:ext cx="2011680" cy="2286000"/>
+          </a:xfrm>
+          <a:prstGeom prst="roundRect">
+            <a:avLst>
+              <a:gd name="adj" fmla="val 4091"/>
+            </a:avLst>
+          </a:prstGeom>
+          <a:solidFill>
+            <a:srgbClr val="FFFFFF"/>
+          </a:solidFill>
+          <a:ln w="12700">
+            <a:solidFill>
+              <a:srgbClr val="D5DEEA"/>
+            </a:solidFill>
+            <a:prstDash val="solid"/>
+          </a:ln>
+          <a:effectLst>
+            <a:outerShdw blurRad="63500" dist="25400" dir="5400000" algn="bl" rotWithShape="0">
+              <a:srgbClr val="9AA7B8">
+                <a:alpha val="28000"/>
+              </a:srgbClr>
+            </a:outerShdw>
+          </a:effectLst>
+        </p:spPr>
+        <p:txBody>
+          <a:bodyPr/>
+          <a:lstStyle/>
+          <a:p>
+            <a:endParaRPr lang="fr-FR"/>
+          </a:p>
+        </p:txBody>
+      </p:sp>
+      <p:sp>
+        <p:nvSpPr>
+          <p:cNvPr id="5" name="Shape 3"/>
+          <p:cNvSpPr/>
+          <p:nvPr/>
+        </p:nvSpPr>
+        <p:spPr>
+          <a:xfrm>
+            <a:off x="1211580" y="1618488"/>
+            <a:ext cx="502920" cy="502920"/>
+          </a:xfrm>
+          <a:prstGeom prst="ellipse">
+            <a:avLst/>
+          </a:prstGeom>
+          <a:solidFill>
+            <a:srgbClr val="1C7C8C"/>
+          </a:solidFill>
+          <a:ln/>
+        </p:spPr>
+        <p:txBody>
+          <a:bodyPr/>
+          <a:lstStyle/>
+          <a:p>
+            <a:endParaRPr lang="fr-FR"/>
+          </a:p>
+        </p:txBody>
+      </p:sp>
+      <p:sp>
+        <p:nvSpPr>
+          <p:cNvPr id="6" name="Text 4"/>
+          <p:cNvSpPr/>
+          <p:nvPr/>
+        </p:nvSpPr>
+        <p:spPr>
+          <a:xfrm>
+            <a:off x="1211580" y="1618488"/>
+            <a:ext cx="502920" cy="502920"/>
+          </a:xfrm>
+          <a:prstGeom prst="rect">
+            <a:avLst/>
+          </a:prstGeom>
+          <a:noFill/>
+          <a:ln/>
+        </p:spPr>
+        <p:txBody>
+          <a:bodyPr wrap="square" lIns="0" tIns="0" rIns="0" bIns="0" rtlCol="0" anchor="ctr"/>
+          <a:lstStyle/>
+          <a:p>
+            <a:pPr marL="0" indent="0" algn="ctr">
+              <a:buNone/>
+            </a:pPr>
+            <a:r>
+              <a:rPr lang="en-US" sz="1800" b="1" dirty="0">
+                <a:solidFill>
+                  <a:srgbClr val="FFFFFF"/>
+                </a:solidFill>
+                <a:latin typeface="Cambria" pitchFamily="34" charset="0"/>
+                <a:ea typeface="Cambria" pitchFamily="34" charset="-122"/>
+                <a:cs typeface="Cambria" pitchFamily="34" charset="-120"/>
+              </a:rPr>
+              <a:t>1</a:t>
+            </a:r>
+            <a:endParaRPr lang="en-US" sz="1800" dirty="0"/>
+          </a:p>
+        </p:txBody>
+      </p:sp>
+      <p:sp>
+        <p:nvSpPr>
+          <p:cNvPr id="7" name="Text 5"/>
+          <p:cNvSpPr/>
+          <p:nvPr/>
+        </p:nvSpPr>
+        <p:spPr>
+          <a:xfrm>
+            <a:off x="566928" y="2258568"/>
+            <a:ext cx="1792224" cy="457200"/>
+          </a:xfrm>
+          <a:prstGeom prst="rect">
+            <a:avLst/>
+          </a:prstGeom>
+          <a:noFill/>
+          <a:ln/>
+        </p:spPr>
+        <p:txBody>
+          <a:bodyPr wrap="square" lIns="0" tIns="0" rIns="0" bIns="0" rtlCol="0" anchor="t"/>
+          <a:lstStyle/>
+          <a:p>
+            <a:pPr marL="0" indent="0" algn="ctr">
+              <a:buNone/>
+            </a:pPr>
+            <a:r>
+              <a:rPr lang="en-US" sz="1300" b="1" dirty="0">
+                <a:solidFill>
+                  <a:srgbClr val="14264A"/>
+                </a:solidFill>
+                <a:latin typeface="Cambria" pitchFamily="34" charset="0"/>
+                <a:ea typeface="Cambria" pitchFamily="34" charset="-122"/>
+                <a:cs typeface="Cambria" pitchFamily="34" charset="-120"/>
+              </a:rPr>
+              <a:t>Une image par patient</a:t>
+            </a:r>
+            <a:endParaRPr lang="en-US" sz="1300" dirty="0"/>
+          </a:p>
+        </p:txBody>
+      </p:sp>
+      <p:sp>
+        <p:nvSpPr>
+          <p:cNvPr id="8" name="Text 6"/>
+          <p:cNvSpPr/>
+          <p:nvPr/>
+        </p:nvSpPr>
+        <p:spPr>
+          <a:xfrm>
+            <a:off x="585216" y="2715768"/>
+            <a:ext cx="1755648" cy="914400"/>
+          </a:xfrm>
+          <a:prstGeom prst="rect">
+            <a:avLst/>
+          </a:prstGeom>
+          <a:noFill/>
+          <a:ln/>
+        </p:spPr>
+        <p:txBody>
+          <a:bodyPr wrap="square" lIns="0" tIns="0" rIns="0" bIns="0" rtlCol="0" anchor="t"/>
+          <a:lstStyle/>
+          <a:p>
+            <a:pPr marL="0" indent="0" algn="ctr">
+              <a:buNone/>
+            </a:pPr>
+            <a:r>
+              <a:rPr lang="en-US" sz="1000" dirty="0">
+                <a:solidFill>
+                  <a:srgbClr val="2A2F36"/>
+                </a:solidFill>
+                <a:latin typeface="Calibri" pitchFamily="34" charset="0"/>
+                <a:ea typeface="Calibri" pitchFamily="34" charset="-122"/>
+                <a:cs typeface="Calibri" pitchFamily="34" charset="-120"/>
+              </a:rPr>
+              <a:t>Jeu CheXpert Plus. Une seule radiographie par patient, tirée au hasard.</a:t>
+            </a:r>
+            <a:endParaRPr lang="en-US" sz="1000" dirty="0"/>
+          </a:p>
+        </p:txBody>
+      </p:sp>
+      <p:sp>
+        <p:nvSpPr>
+          <p:cNvPr id="9" name="Shape 7"/>
+          <p:cNvSpPr/>
+          <p:nvPr/>
+        </p:nvSpPr>
+        <p:spPr>
+          <a:xfrm>
+            <a:off x="2487168" y="2560320"/>
+            <a:ext cx="214884" cy="0"/>
+          </a:xfrm>
+          <a:prstGeom prst="line">
+            <a:avLst/>
+          </a:prstGeom>
+          <a:noFill/>
+          <a:ln w="25400">
+            <a:solidFill>
+              <a:srgbClr val="14264A"/>
+            </a:solidFill>
+            <a:prstDash val="solid"/>
+            <a:headEnd type="none"/>
+            <a:tailEnd type="triangle"/>
+          </a:ln>
+        </p:spPr>
+        <p:txBody>
+          <a:bodyPr/>
+          <a:lstStyle/>
+          <a:p>
+            <a:endParaRPr lang="fr-FR"/>
+          </a:p>
+        </p:txBody>
+      </p:sp>
+      <p:sp>
+        <p:nvSpPr>
+          <p:cNvPr id="10" name="Shape 8"/>
+          <p:cNvSpPr/>
+          <p:nvPr/>
+        </p:nvSpPr>
+        <p:spPr>
+          <a:xfrm>
+            <a:off x="2720340" y="1417320"/>
+            <a:ext cx="2011680" cy="2286000"/>
+          </a:xfrm>
+          <a:prstGeom prst="roundRect">
+            <a:avLst>
+              <a:gd name="adj" fmla="val 4091"/>
+            </a:avLst>
+          </a:prstGeom>
+          <a:solidFill>
+            <a:srgbClr val="FFFFFF"/>
+          </a:solidFill>
+          <a:ln w="12700">
+            <a:solidFill>
+              <a:srgbClr val="D5DEEA"/>
+            </a:solidFill>
+            <a:prstDash val="solid"/>
+          </a:ln>
+          <a:effectLst>
+            <a:outerShdw blurRad="63500" dist="25400" dir="5400000" algn="bl" rotWithShape="0">
+              <a:srgbClr val="9AA7B8">
+                <a:alpha val="28000"/>
+              </a:srgbClr>
+            </a:outerShdw>
+          </a:effectLst>
+        </p:spPr>
+        <p:txBody>
+          <a:bodyPr/>
+          <a:lstStyle/>
+          <a:p>
+            <a:endParaRPr lang="fr-FR"/>
+          </a:p>
+        </p:txBody>
+      </p:sp>
+      <p:sp>
+        <p:nvSpPr>
+          <p:cNvPr id="11" name="Shape 9"/>
+          <p:cNvSpPr/>
+          <p:nvPr/>
+        </p:nvSpPr>
+        <p:spPr>
+          <a:xfrm>
+            <a:off x="3474720" y="1618488"/>
+            <a:ext cx="502920" cy="502920"/>
+          </a:xfrm>
+          <a:prstGeom prst="ellipse">
+            <a:avLst/>
+          </a:prstGeom>
+          <a:solidFill>
+            <a:srgbClr val="1C7C8C"/>
+          </a:solidFill>
+          <a:ln/>
+        </p:spPr>
+        <p:txBody>
+          <a:bodyPr/>
+          <a:lstStyle/>
+          <a:p>
+            <a:endParaRPr lang="fr-FR"/>
+          </a:p>
+        </p:txBody>
+      </p:sp>
+      <p:sp>
+        <p:nvSpPr>
+          <p:cNvPr id="12" name="Text 10"/>
+          <p:cNvSpPr/>
+          <p:nvPr/>
+        </p:nvSpPr>
+        <p:spPr>
+          <a:xfrm>
+            <a:off x="3474720" y="1618488"/>
+            <a:ext cx="502920" cy="502920"/>
+          </a:xfrm>
+          <a:prstGeom prst="rect">
+            <a:avLst/>
+          </a:prstGeom>
+          <a:noFill/>
+          <a:ln/>
+        </p:spPr>
+        <p:txBody>
+          <a:bodyPr wrap="square" lIns="0" tIns="0" rIns="0" bIns="0" rtlCol="0" anchor="ctr"/>
+          <a:lstStyle/>
+          <a:p>
+            <a:pPr marL="0" indent="0" algn="ctr">
+              <a:buNone/>
+            </a:pPr>
+            <a:r>
+              <a:rPr lang="en-US" sz="1800" b="1" dirty="0">
+                <a:solidFill>
+                  <a:srgbClr val="FFFFFF"/>
+                </a:solidFill>
+                <a:latin typeface="Cambria" pitchFamily="34" charset="0"/>
+                <a:ea typeface="Cambria" pitchFamily="34" charset="-122"/>
+                <a:cs typeface="Cambria" pitchFamily="34" charset="-120"/>
+              </a:rPr>
+              <a:t>2</a:t>
+            </a:r>
+            <a:endParaRPr lang="en-US" sz="1800" dirty="0"/>
+          </a:p>
+        </p:txBody>
+      </p:sp>
+      <p:sp>
+        <p:nvSpPr>
+          <p:cNvPr id="13" name="Text 11"/>
+          <p:cNvSpPr/>
+          <p:nvPr/>
+        </p:nvSpPr>
+        <p:spPr>
+          <a:xfrm>
+            <a:off x="2830068" y="2258568"/>
+            <a:ext cx="1792224" cy="457200"/>
+          </a:xfrm>
+          <a:prstGeom prst="rect">
+            <a:avLst/>
+          </a:prstGeom>
+          <a:noFill/>
+          <a:ln/>
+        </p:spPr>
+        <p:txBody>
+          <a:bodyPr wrap="square" lIns="0" tIns="0" rIns="0" bIns="0" rtlCol="0" anchor="t"/>
+          <a:lstStyle/>
+          <a:p>
+            <a:pPr marL="0" indent="0" algn="ctr">
+              <a:buNone/>
+            </a:pPr>
+            <a:r>
+              <a:rPr lang="en-US" sz="1300" b="1" dirty="0">
+                <a:solidFill>
+                  <a:srgbClr val="14264A"/>
+                </a:solidFill>
+                <a:latin typeface="Cambria" pitchFamily="34" charset="0"/>
+                <a:ea typeface="Cambria" pitchFamily="34" charset="-122"/>
+                <a:cs typeface="Cambria" pitchFamily="34" charset="-120"/>
+              </a:rPr>
+              <a:t>Deux groupes</a:t>
+            </a:r>
+            <a:endParaRPr lang="en-US" sz="1300" dirty="0"/>
+          </a:p>
+        </p:txBody>
+      </p:sp>
+      <p:sp>
+        <p:nvSpPr>
+          <p:cNvPr id="14" name="Text 12"/>
+          <p:cNvSpPr/>
+          <p:nvPr/>
+        </p:nvSpPr>
+        <p:spPr>
+          <a:xfrm>
+            <a:off x="2848356" y="2715768"/>
+            <a:ext cx="1755648" cy="914400"/>
+          </a:xfrm>
+          <a:prstGeom prst="rect">
+            <a:avLst/>
+          </a:prstGeom>
+          <a:noFill/>
+          <a:ln/>
+        </p:spPr>
+        <p:txBody>
+          <a:bodyPr wrap="square" lIns="0" tIns="0" rIns="0" bIns="0" rtlCol="0" anchor="t"/>
+          <a:lstStyle/>
+          <a:p>
+            <a:pPr marL="0" indent="0" algn="ctr">
+              <a:buNone/>
+            </a:pPr>
+            <a:r>
+              <a:rPr lang="en-US" sz="1000" dirty="0">
+                <a:solidFill>
+                  <a:srgbClr val="2A2F36"/>
+                </a:solidFill>
+                <a:latin typeface="Calibri" pitchFamily="34" charset="0"/>
+                <a:ea typeface="Calibri" pitchFamily="34" charset="-122"/>
+                <a:cs typeface="Calibri" pitchFamily="34" charset="-120"/>
+              </a:rPr>
+              <a:t>Cohérent : garde son vrai rapport. Incohérent : recevra un autre rapport.</a:t>
+            </a:r>
+            <a:endParaRPr lang="en-US" sz="1000" dirty="0"/>
+          </a:p>
+        </p:txBody>
+      </p:sp>
+      <p:sp>
+        <p:nvSpPr>
+          <p:cNvPr id="15" name="Shape 13"/>
+          <p:cNvSpPr/>
+          <p:nvPr/>
+        </p:nvSpPr>
+        <p:spPr>
+          <a:xfrm>
+            <a:off x="4750308" y="2560320"/>
+            <a:ext cx="214884" cy="0"/>
+          </a:xfrm>
+          <a:prstGeom prst="line">
+            <a:avLst/>
+          </a:prstGeom>
+          <a:noFill/>
+          <a:ln w="25400">
+            <a:solidFill>
+              <a:srgbClr val="14264A"/>
+            </a:solidFill>
+            <a:prstDash val="solid"/>
+            <a:headEnd type="none"/>
+            <a:tailEnd type="triangle"/>
+          </a:ln>
+        </p:spPr>
+        <p:txBody>
+          <a:bodyPr/>
+          <a:lstStyle/>
+          <a:p>
+            <a:endParaRPr lang="fr-FR"/>
+          </a:p>
+        </p:txBody>
+      </p:sp>
+      <p:sp>
+        <p:nvSpPr>
+          <p:cNvPr id="16" name="Shape 14"/>
+          <p:cNvSpPr/>
+          <p:nvPr/>
+        </p:nvSpPr>
+        <p:spPr>
+          <a:xfrm>
+            <a:off x="4983480" y="1417320"/>
+            <a:ext cx="2011680" cy="2286000"/>
+          </a:xfrm>
+          <a:prstGeom prst="roundRect">
+            <a:avLst>
+              <a:gd name="adj" fmla="val 4091"/>
+            </a:avLst>
+          </a:prstGeom>
+          <a:solidFill>
+            <a:srgbClr val="FFFFFF"/>
+          </a:solidFill>
+          <a:ln w="12700">
+            <a:solidFill>
+              <a:srgbClr val="D5DEEA"/>
+            </a:solidFill>
+            <a:prstDash val="solid"/>
+          </a:ln>
+          <a:effectLst>
+            <a:outerShdw blurRad="63500" dist="25400" dir="5400000" algn="bl" rotWithShape="0">
+              <a:srgbClr val="9AA7B8">
+                <a:alpha val="28000"/>
+              </a:srgbClr>
+            </a:outerShdw>
+          </a:effectLst>
+        </p:spPr>
+        <p:txBody>
+          <a:bodyPr/>
+          <a:lstStyle/>
+          <a:p>
+            <a:endParaRPr lang="fr-FR"/>
+          </a:p>
+        </p:txBody>
+      </p:sp>
+      <p:sp>
+        <p:nvSpPr>
+          <p:cNvPr id="17" name="Shape 15"/>
+          <p:cNvSpPr/>
+          <p:nvPr/>
+        </p:nvSpPr>
+        <p:spPr>
+          <a:xfrm>
+            <a:off x="5737860" y="1618488"/>
+            <a:ext cx="502920" cy="502920"/>
+          </a:xfrm>
+          <a:prstGeom prst="ellipse">
+            <a:avLst/>
+          </a:prstGeom>
+          <a:solidFill>
+            <a:srgbClr val="1C7C8C"/>
+          </a:solidFill>
+          <a:ln/>
+        </p:spPr>
+        <p:txBody>
+          <a:bodyPr/>
+          <a:lstStyle/>
+          <a:p>
+            <a:endParaRPr lang="fr-FR"/>
+          </a:p>
+        </p:txBody>
+      </p:sp>
+      <p:sp>
+        <p:nvSpPr>
+          <p:cNvPr id="18" name="Text 16"/>
+          <p:cNvSpPr/>
+          <p:nvPr/>
+        </p:nvSpPr>
+        <p:spPr>
+          <a:xfrm>
+            <a:off x="5737860" y="1618488"/>
+            <a:ext cx="502920" cy="502920"/>
+          </a:xfrm>
+          <a:prstGeom prst="rect">
+            <a:avLst/>
+          </a:prstGeom>
+          <a:noFill/>
+          <a:ln/>
+        </p:spPr>
+        <p:txBody>
+          <a:bodyPr wrap="square" lIns="0" tIns="0" rIns="0" bIns="0" rtlCol="0" anchor="ctr"/>
+          <a:lstStyle/>
+          <a:p>
+            <a:pPr marL="0" indent="0" algn="ctr">
+              <a:buNone/>
+            </a:pPr>
+            <a:r>
+              <a:rPr lang="en-US" sz="1800" b="1" dirty="0">
+                <a:solidFill>
+                  <a:srgbClr val="FFFFFF"/>
+                </a:solidFill>
+                <a:latin typeface="Cambria" pitchFamily="34" charset="0"/>
+                <a:ea typeface="Cambria" pitchFamily="34" charset="-122"/>
+                <a:cs typeface="Cambria" pitchFamily="34" charset="-120"/>
+              </a:rPr>
+              <a:t>3</a:t>
+            </a:r>
+            <a:endParaRPr lang="en-US" sz="1800" dirty="0"/>
+          </a:p>
+        </p:txBody>
+      </p:sp>
+      <p:sp>
+        <p:nvSpPr>
+          <p:cNvPr id="19" name="Text 17"/>
+          <p:cNvSpPr/>
+          <p:nvPr/>
+        </p:nvSpPr>
+        <p:spPr>
+          <a:xfrm>
+            <a:off x="5093208" y="2258568"/>
+            <a:ext cx="1792224" cy="457200"/>
+          </a:xfrm>
+          <a:prstGeom prst="rect">
+            <a:avLst/>
+          </a:prstGeom>
+          <a:noFill/>
+          <a:ln/>
+        </p:spPr>
+        <p:txBody>
+          <a:bodyPr wrap="square" lIns="0" tIns="0" rIns="0" bIns="0" rtlCol="0" anchor="t"/>
+          <a:lstStyle/>
+          <a:p>
+            <a:pPr marL="0" indent="0" algn="ctr">
+              <a:buNone/>
+            </a:pPr>
+            <a:r>
+              <a:rPr lang="en-US" sz="1300" b="1" dirty="0">
+                <a:solidFill>
+                  <a:srgbClr val="14264A"/>
+                </a:solidFill>
+                <a:latin typeface="Cambria" pitchFamily="34" charset="0"/>
+                <a:ea typeface="Cambria" pitchFamily="34" charset="-122"/>
+                <a:cs typeface="Cambria" pitchFamily="34" charset="-120"/>
+              </a:rPr>
+              <a:t>Étiquettes de pathologies</a:t>
+            </a:r>
+            <a:endParaRPr lang="en-US" sz="1300" dirty="0"/>
+          </a:p>
+        </p:txBody>
+      </p:sp>
+      <p:sp>
+        <p:nvSpPr>
+          <p:cNvPr id="20" name="Text 18"/>
+          <p:cNvSpPr/>
+          <p:nvPr/>
+        </p:nvSpPr>
+        <p:spPr>
+          <a:xfrm>
+            <a:off x="5111496" y="2715768"/>
+            <a:ext cx="1755648" cy="914400"/>
+          </a:xfrm>
+          <a:prstGeom prst="rect">
+            <a:avLst/>
+          </a:prstGeom>
+          <a:noFill/>
+          <a:ln/>
+        </p:spPr>
+        <p:txBody>
+          <a:bodyPr wrap="square" lIns="0" tIns="0" rIns="0" bIns="0" rtlCol="0" anchor="t"/>
+          <a:lstStyle/>
+          <a:p>
+            <a:pPr marL="0" indent="0" algn="ctr">
+              <a:buNone/>
+            </a:pPr>
+            <a:r>
+              <a:rPr lang="en-US" sz="1000" dirty="0">
+                <a:solidFill>
+                  <a:srgbClr val="2A2F36"/>
+                </a:solidFill>
+                <a:latin typeface="Calibri" pitchFamily="34" charset="0"/>
+                <a:ea typeface="Calibri" pitchFamily="34" charset="-122"/>
+                <a:cs typeface="Calibri" pitchFamily="34" charset="-120"/>
+              </a:rPr>
+              <a:t>Chaque rapport devient un vecteur de 12 pathologies (source CheXbert).</a:t>
+            </a:r>
+            <a:endParaRPr lang="en-US" sz="1000" dirty="0"/>
+          </a:p>
+        </p:txBody>
+      </p:sp>
+      <p:sp>
+        <p:nvSpPr>
+          <p:cNvPr id="21" name="Shape 19"/>
+          <p:cNvSpPr/>
+          <p:nvPr/>
+        </p:nvSpPr>
+        <p:spPr>
+          <a:xfrm>
+            <a:off x="7013448" y="2560320"/>
+            <a:ext cx="214884" cy="0"/>
+          </a:xfrm>
+          <a:prstGeom prst="line">
+            <a:avLst/>
+          </a:prstGeom>
+          <a:noFill/>
+          <a:ln w="25400">
+            <a:solidFill>
+              <a:srgbClr val="14264A"/>
+            </a:solidFill>
+            <a:prstDash val="solid"/>
+            <a:headEnd type="none"/>
+            <a:tailEnd type="triangle"/>
+          </a:ln>
+        </p:spPr>
+        <p:txBody>
+          <a:bodyPr/>
+          <a:lstStyle/>
+          <a:p>
+            <a:endParaRPr lang="fr-FR"/>
+          </a:p>
+        </p:txBody>
+      </p:sp>
+      <p:sp>
+        <p:nvSpPr>
+          <p:cNvPr id="22" name="Shape 20"/>
+          <p:cNvSpPr/>
+          <p:nvPr/>
+        </p:nvSpPr>
+        <p:spPr>
+          <a:xfrm>
+            <a:off x="7246620" y="1417320"/>
+            <a:ext cx="2011680" cy="2286000"/>
+          </a:xfrm>
+          <a:prstGeom prst="roundRect">
+            <a:avLst>
+              <a:gd name="adj" fmla="val 4091"/>
+            </a:avLst>
+          </a:prstGeom>
+          <a:solidFill>
+            <a:srgbClr val="FFFFFF"/>
+          </a:solidFill>
+          <a:ln w="12700">
+            <a:solidFill>
+              <a:srgbClr val="D5DEEA"/>
+            </a:solidFill>
+            <a:prstDash val="solid"/>
+          </a:ln>
+          <a:effectLst>
+            <a:outerShdw blurRad="63500" dist="25400" dir="5400000" algn="bl" rotWithShape="0">
+              <a:srgbClr val="9AA7B8">
+                <a:alpha val="28000"/>
+              </a:srgbClr>
+            </a:outerShdw>
+          </a:effectLst>
+        </p:spPr>
+        <p:txBody>
+          <a:bodyPr/>
+          <a:lstStyle/>
+          <a:p>
+            <a:endParaRPr lang="fr-FR"/>
+          </a:p>
+        </p:txBody>
+      </p:sp>
+      <p:sp>
+        <p:nvSpPr>
+          <p:cNvPr id="23" name="Shape 21"/>
+          <p:cNvSpPr/>
+          <p:nvPr/>
+        </p:nvSpPr>
+        <p:spPr>
+          <a:xfrm>
+            <a:off x="8001000" y="1618488"/>
+            <a:ext cx="502920" cy="502920"/>
+          </a:xfrm>
+          <a:prstGeom prst="ellipse">
+            <a:avLst/>
+          </a:prstGeom>
+          <a:solidFill>
+            <a:srgbClr val="1C7C8C"/>
+          </a:solidFill>
+          <a:ln/>
+        </p:spPr>
+        <p:txBody>
+          <a:bodyPr/>
+          <a:lstStyle/>
+          <a:p>
+            <a:endParaRPr lang="fr-FR"/>
+          </a:p>
+        </p:txBody>
+      </p:sp>
+      <p:sp>
+        <p:nvSpPr>
+          <p:cNvPr id="24" name="Text 22"/>
+          <p:cNvSpPr/>
+          <p:nvPr/>
+        </p:nvSpPr>
+        <p:spPr>
+          <a:xfrm>
+            <a:off x="8001000" y="1618488"/>
+            <a:ext cx="502920" cy="502920"/>
+          </a:xfrm>
+          <a:prstGeom prst="rect">
+            <a:avLst/>
+          </a:prstGeom>
+          <a:noFill/>
+          <a:ln/>
+        </p:spPr>
+        <p:txBody>
+          <a:bodyPr wrap="square" lIns="0" tIns="0" rIns="0" bIns="0" rtlCol="0" anchor="ctr"/>
+          <a:lstStyle/>
+          <a:p>
+            <a:pPr marL="0" indent="0" algn="ctr">
+              <a:buNone/>
+            </a:pPr>
+            <a:r>
+              <a:rPr lang="en-US" sz="1800" b="1" dirty="0">
+                <a:solidFill>
+                  <a:srgbClr val="FFFFFF"/>
+                </a:solidFill>
+                <a:latin typeface="Cambria" pitchFamily="34" charset="0"/>
+                <a:ea typeface="Cambria" pitchFamily="34" charset="-122"/>
+                <a:cs typeface="Cambria" pitchFamily="34" charset="-120"/>
+              </a:rPr>
+              <a:t>4</a:t>
+            </a:r>
+            <a:endParaRPr lang="en-US" sz="1800" dirty="0"/>
+          </a:p>
+        </p:txBody>
+      </p:sp>
+      <p:sp>
+        <p:nvSpPr>
+          <p:cNvPr id="25" name="Text 23"/>
+          <p:cNvSpPr/>
+          <p:nvPr/>
+        </p:nvSpPr>
+        <p:spPr>
+          <a:xfrm>
+            <a:off x="7356348" y="2258568"/>
+            <a:ext cx="1792224" cy="457200"/>
+          </a:xfrm>
+          <a:prstGeom prst="rect">
+            <a:avLst/>
+          </a:prstGeom>
+          <a:noFill/>
+          <a:ln/>
+        </p:spPr>
+        <p:txBody>
+          <a:bodyPr wrap="square" lIns="0" tIns="0" rIns="0" bIns="0" rtlCol="0" anchor="t"/>
+          <a:lstStyle/>
+          <a:p>
+            <a:pPr marL="0" indent="0" algn="ctr">
+              <a:buNone/>
+            </a:pPr>
+            <a:r>
+              <a:rPr lang="en-US" sz="1300" b="1" dirty="0">
+                <a:solidFill>
+                  <a:srgbClr val="14264A"/>
+                </a:solidFill>
+                <a:latin typeface="Cambria" pitchFamily="34" charset="0"/>
+                <a:ea typeface="Cambria" pitchFamily="34" charset="-122"/>
+                <a:cs typeface="Cambria" pitchFamily="34" charset="-120"/>
+              </a:rPr>
+              <a:t>Échange contrôlé</a:t>
+            </a:r>
+            <a:endParaRPr lang="en-US" sz="1300" dirty="0"/>
+          </a:p>
+        </p:txBody>
+      </p:sp>
+      <p:sp>
+        <p:nvSpPr>
+          <p:cNvPr id="26" name="Text 24"/>
+          <p:cNvSpPr/>
+          <p:nvPr/>
+        </p:nvSpPr>
+        <p:spPr>
+          <a:xfrm>
+            <a:off x="7374636" y="2715768"/>
+            <a:ext cx="1755648" cy="914400"/>
+          </a:xfrm>
+          <a:prstGeom prst="rect">
+            <a:avLst/>
+          </a:prstGeom>
+          <a:noFill/>
+          <a:ln/>
+        </p:spPr>
+        <p:txBody>
+          <a:bodyPr wrap="square" lIns="0" tIns="0" rIns="0" bIns="0" rtlCol="0" anchor="t"/>
+          <a:lstStyle/>
+          <a:p>
+            <a:pPr marL="0" indent="0" algn="ctr">
+              <a:buNone/>
+            </a:pPr>
+            <a:r>
+              <a:rPr lang="en-US" sz="1000" dirty="0">
+                <a:solidFill>
+                  <a:srgbClr val="2A2F36"/>
+                </a:solidFill>
+                <a:latin typeface="Calibri" pitchFamily="34" charset="0"/>
+                <a:ea typeface="Calibri" pitchFamily="34" charset="-122"/>
+                <a:cs typeface="Calibri" pitchFamily="34" charset="-120"/>
+              </a:rPr>
+              <a:t>On classe l'incohérence (totale, nette, ambiguë) sous quotas. Un rapport utilisé une seule fois.</a:t>
+            </a:r>
+            <a:endParaRPr lang="en-US" sz="1000" dirty="0"/>
+          </a:p>
+        </p:txBody>
+      </p:sp>
+      <p:sp>
+        <p:nvSpPr>
+          <p:cNvPr id="27" name="Shape 25"/>
+          <p:cNvSpPr/>
+          <p:nvPr/>
+        </p:nvSpPr>
+        <p:spPr>
+          <a:xfrm>
+            <a:off x="9276588" y="2560320"/>
+            <a:ext cx="214884" cy="0"/>
+          </a:xfrm>
+          <a:prstGeom prst="line">
+            <a:avLst/>
+          </a:prstGeom>
+          <a:noFill/>
+          <a:ln w="25400">
+            <a:solidFill>
+              <a:srgbClr val="14264A"/>
+            </a:solidFill>
+            <a:prstDash val="solid"/>
+            <a:headEnd type="none"/>
+            <a:tailEnd type="triangle"/>
+          </a:ln>
+        </p:spPr>
+        <p:txBody>
+          <a:bodyPr/>
+          <a:lstStyle/>
+          <a:p>
+            <a:endParaRPr lang="fr-FR"/>
+          </a:p>
+        </p:txBody>
+      </p:sp>
+      <p:sp>
+        <p:nvSpPr>
+          <p:cNvPr id="28" name="Shape 26"/>
+          <p:cNvSpPr/>
+          <p:nvPr/>
+        </p:nvSpPr>
+        <p:spPr>
+          <a:xfrm>
+            <a:off x="9509760" y="1417320"/>
+            <a:ext cx="2011680" cy="2286000"/>
+          </a:xfrm>
+          <a:prstGeom prst="roundRect">
+            <a:avLst>
+              <a:gd name="adj" fmla="val 4091"/>
+            </a:avLst>
+          </a:prstGeom>
+          <a:solidFill>
+            <a:srgbClr val="14264A"/>
+          </a:solidFill>
+          <a:ln w="12700">
+            <a:solidFill>
+              <a:srgbClr val="14264A"/>
+            </a:solidFill>
+            <a:prstDash val="solid"/>
+          </a:ln>
+          <a:effectLst>
+            <a:outerShdw blurRad="63500" dist="25400" dir="5400000" algn="bl" rotWithShape="0">
+              <a:srgbClr val="9AA7B8">
+                <a:alpha val="28000"/>
+              </a:srgbClr>
+            </a:outerShdw>
+          </a:effectLst>
+        </p:spPr>
+        <p:txBody>
+          <a:bodyPr/>
+          <a:lstStyle/>
+          <a:p>
+            <a:endParaRPr lang="fr-FR"/>
+          </a:p>
+        </p:txBody>
+      </p:sp>
+      <p:sp>
+        <p:nvSpPr>
+          <p:cNvPr id="29" name="Shape 27"/>
+          <p:cNvSpPr/>
+          <p:nvPr/>
+        </p:nvSpPr>
+        <p:spPr>
+          <a:xfrm>
+            <a:off x="10264140" y="1618488"/>
+            <a:ext cx="502920" cy="502920"/>
+          </a:xfrm>
+          <a:prstGeom prst="ellipse">
+            <a:avLst/>
+          </a:prstGeom>
+          <a:solidFill>
+            <a:srgbClr val="FFFFFF"/>
+          </a:solidFill>
+          <a:ln/>
+        </p:spPr>
+        <p:txBody>
+          <a:bodyPr/>
+          <a:lstStyle/>
+          <a:p>
+            <a:endParaRPr lang="fr-FR"/>
+          </a:p>
+        </p:txBody>
+      </p:sp>
+      <p:sp>
+        <p:nvSpPr>
+          <p:cNvPr id="30" name="Text 28"/>
+          <p:cNvSpPr/>
+          <p:nvPr/>
+        </p:nvSpPr>
+        <p:spPr>
+          <a:xfrm>
+            <a:off x="10264140" y="1618488"/>
+            <a:ext cx="502920" cy="502920"/>
+          </a:xfrm>
+          <a:prstGeom prst="rect">
+            <a:avLst/>
+          </a:prstGeom>
+          <a:noFill/>
+          <a:ln/>
+        </p:spPr>
+        <p:txBody>
+          <a:bodyPr wrap="square" lIns="0" tIns="0" rIns="0" bIns="0" rtlCol="0" anchor="ctr"/>
+          <a:lstStyle/>
+          <a:p>
+            <a:pPr marL="0" indent="0" algn="ctr">
+              <a:buNone/>
+            </a:pPr>
+            <a:r>
+              <a:rPr lang="en-US" sz="1800" b="1" dirty="0">
+                <a:solidFill>
+                  <a:srgbClr val="14264A"/>
+                </a:solidFill>
+                <a:latin typeface="Cambria" pitchFamily="34" charset="0"/>
+                <a:ea typeface="Cambria" pitchFamily="34" charset="-122"/>
+                <a:cs typeface="Cambria" pitchFamily="34" charset="-120"/>
+              </a:rPr>
+              <a:t>5</a:t>
+            </a:r>
+            <a:endParaRPr lang="en-US" sz="1800" dirty="0"/>
+          </a:p>
+        </p:txBody>
+      </p:sp>
+      <p:sp>
+        <p:nvSpPr>
+          <p:cNvPr id="31" name="Text 29"/>
+          <p:cNvSpPr/>
+          <p:nvPr/>
+        </p:nvSpPr>
+        <p:spPr>
+          <a:xfrm>
+            <a:off x="9619488" y="2258568"/>
+            <a:ext cx="1792224" cy="457200"/>
+          </a:xfrm>
+          <a:prstGeom prst="rect">
+            <a:avLst/>
+          </a:prstGeom>
+          <a:noFill/>
+          <a:ln/>
+        </p:spPr>
+        <p:txBody>
+          <a:bodyPr wrap="square" lIns="0" tIns="0" rIns="0" bIns="0" rtlCol="0" anchor="t"/>
+          <a:lstStyle/>
+          <a:p>
+            <a:pPr marL="0" indent="0" algn="ctr">
+              <a:buNone/>
+            </a:pPr>
+            <a:r>
+              <a:rPr lang="en-US" sz="1300" b="1" dirty="0">
+                <a:solidFill>
+                  <a:srgbClr val="FFFFFF"/>
+                </a:solidFill>
+                <a:latin typeface="Cambria" pitchFamily="34" charset="0"/>
+                <a:ea typeface="Cambria" pitchFamily="34" charset="-122"/>
+                <a:cs typeface="Cambria" pitchFamily="34" charset="-120"/>
+              </a:rPr>
+              <a:t>36 000 paires</a:t>
+            </a:r>
+            <a:endParaRPr lang="en-US" sz="1300" dirty="0"/>
+          </a:p>
+        </p:txBody>
+      </p:sp>
+      <p:sp>
+        <p:nvSpPr>
+          <p:cNvPr id="32" name="Text 30"/>
+          <p:cNvSpPr/>
+          <p:nvPr/>
+        </p:nvSpPr>
+        <p:spPr>
+          <a:xfrm>
+            <a:off x="9637776" y="2715768"/>
+            <a:ext cx="1755648" cy="914400"/>
+          </a:xfrm>
+          <a:prstGeom prst="rect">
+            <a:avLst/>
+          </a:prstGeom>
+          <a:noFill/>
+          <a:ln/>
+        </p:spPr>
+        <p:txBody>
+          <a:bodyPr wrap="square" lIns="0" tIns="0" rIns="0" bIns="0" rtlCol="0" anchor="t"/>
+          <a:lstStyle/>
+          <a:p>
+            <a:pPr marL="0" indent="0" algn="ctr">
+              <a:buNone/>
+            </a:pPr>
+            <a:r>
+              <a:rPr lang="en-US" sz="1000" dirty="0">
+                <a:solidFill>
+                  <a:srgbClr val="DDE6F2"/>
+                </a:solidFill>
+                <a:latin typeface="Calibri" pitchFamily="34" charset="0"/>
+                <a:ea typeface="Calibri" pitchFamily="34" charset="-122"/>
+                <a:cs typeface="Calibri" pitchFamily="34" charset="-120"/>
+              </a:rPr>
+              <a:t>18 000 cohérentes et 18 000 incohérentes, mélangées et enregistrées.</a:t>
+            </a:r>
+            <a:endParaRPr lang="en-US" sz="1000" dirty="0"/>
+          </a:p>
+        </p:txBody>
+      </p:sp>
+      <p:sp>
+        <p:nvSpPr>
+          <p:cNvPr id="33" name="Text 31"/>
+          <p:cNvSpPr/>
+          <p:nvPr/>
+        </p:nvSpPr>
+        <p:spPr>
+          <a:xfrm>
+            <a:off x="457200" y="4160520"/>
+            <a:ext cx="11247120" cy="320040"/>
+          </a:xfrm>
+          <a:prstGeom prst="rect">
+            <a:avLst/>
+          </a:prstGeom>
+          <a:noFill/>
+          <a:ln/>
+        </p:spPr>
+        <p:txBody>
+          <a:bodyPr wrap="square" lIns="0" tIns="0" rIns="0" bIns="0" rtlCol="0" anchor="ctr"/>
+          <a:lstStyle/>
+          <a:p>
+            <a:pPr marL="0" indent="0" algn="l">
+              <a:buNone/>
+            </a:pPr>
+            <a:r>
+              <a:rPr lang="en-US" sz="1400" b="1" dirty="0">
+                <a:solidFill>
+                  <a:srgbClr val="14264A"/>
+                </a:solidFill>
+                <a:latin typeface="Cambria" pitchFamily="34" charset="0"/>
+                <a:ea typeface="Cambria" pitchFamily="34" charset="-122"/>
+                <a:cs typeface="Cambria" pitchFamily="34" charset="-120"/>
+              </a:rPr>
+              <a:t>La répartition imposée par les quotas</a:t>
+            </a:r>
+            <a:endParaRPr lang="en-US" sz="1400" dirty="0"/>
+          </a:p>
+        </p:txBody>
+      </p:sp>
+      <p:sp>
+        <p:nvSpPr>
+          <p:cNvPr id="34" name="Shape 32"/>
+          <p:cNvSpPr/>
+          <p:nvPr/>
+        </p:nvSpPr>
+        <p:spPr>
+          <a:xfrm>
+            <a:off x="457200" y="4572000"/>
+            <a:ext cx="4498848" cy="777240"/>
+          </a:xfrm>
+          <a:prstGeom prst="rect">
+            <a:avLst/>
+          </a:prstGeom>
+          <a:solidFill>
+            <a:srgbClr val="14264A"/>
+          </a:solidFill>
+          <a:ln/>
+        </p:spPr>
+        <p:txBody>
+          <a:bodyPr/>
+          <a:lstStyle/>
+          <a:p>
+            <a:endParaRPr lang="fr-FR"/>
+          </a:p>
+        </p:txBody>
+      </p:sp>
+      <p:sp>
+        <p:nvSpPr>
+          <p:cNvPr id="35" name="Text 33"/>
+          <p:cNvSpPr/>
+          <p:nvPr/>
+        </p:nvSpPr>
+        <p:spPr>
+          <a:xfrm>
+            <a:off x="457200" y="4572000"/>
+            <a:ext cx="4498848" cy="777240"/>
+          </a:xfrm>
+          <a:prstGeom prst="rect">
+            <a:avLst/>
+          </a:prstGeom>
+          <a:noFill/>
+          <a:ln/>
+        </p:spPr>
+        <p:txBody>
+          <a:bodyPr wrap="square" lIns="0" tIns="0" rIns="0" bIns="0" rtlCol="0" anchor="ctr"/>
+          <a:lstStyle/>
+          <a:p>
+            <a:pPr marL="0" indent="0" algn="ctr">
+              <a:buNone/>
+            </a:pPr>
+            <a:r>
+              <a:rPr lang="en-US" sz="1500" b="1" dirty="0">
+                <a:solidFill>
+                  <a:srgbClr val="FFFFFF"/>
+                </a:solidFill>
+                <a:latin typeface="Cambria" pitchFamily="34" charset="0"/>
+                <a:ea typeface="Cambria" pitchFamily="34" charset="-122"/>
+                <a:cs typeface="Cambria" pitchFamily="34" charset="-120"/>
+              </a:rPr>
+              <a:t>40 %</a:t>
+            </a:r>
+            <a:endParaRPr lang="en-US" sz="1500" dirty="0"/>
+          </a:p>
+          <a:p>
+            <a:pPr marL="0" indent="0" algn="ctr">
+              <a:buNone/>
+            </a:pPr>
+            <a:r>
+              <a:rPr lang="en-US" sz="950" dirty="0">
+                <a:solidFill>
+                  <a:srgbClr val="FFFFFF"/>
+                </a:solidFill>
+                <a:latin typeface="Calibri" pitchFamily="34" charset="0"/>
+                <a:ea typeface="Calibri" pitchFamily="34" charset="-122"/>
+                <a:cs typeface="Calibri" pitchFamily="34" charset="-120"/>
+              </a:rPr>
+              <a:t>Incohérence totale</a:t>
+            </a:r>
+            <a:endParaRPr lang="en-US" sz="1500" dirty="0"/>
+          </a:p>
+        </p:txBody>
+      </p:sp>
+      <p:sp>
+        <p:nvSpPr>
+          <p:cNvPr id="36" name="Shape 34"/>
+          <p:cNvSpPr/>
+          <p:nvPr/>
+        </p:nvSpPr>
+        <p:spPr>
+          <a:xfrm>
+            <a:off x="4956048" y="4572000"/>
+            <a:ext cx="2699309" cy="777240"/>
+          </a:xfrm>
+          <a:prstGeom prst="rect">
+            <a:avLst/>
+          </a:prstGeom>
+          <a:solidFill>
+            <a:srgbClr val="1C7C8C"/>
+          </a:solidFill>
+          <a:ln/>
+        </p:spPr>
+        <p:txBody>
+          <a:bodyPr/>
+          <a:lstStyle/>
+          <a:p>
+            <a:endParaRPr lang="fr-FR"/>
+          </a:p>
+        </p:txBody>
+      </p:sp>
+      <p:sp>
+        <p:nvSpPr>
+          <p:cNvPr id="37" name="Text 35"/>
+          <p:cNvSpPr/>
+          <p:nvPr/>
+        </p:nvSpPr>
+        <p:spPr>
+          <a:xfrm>
+            <a:off x="4956048" y="4572000"/>
+            <a:ext cx="2699309" cy="777240"/>
+          </a:xfrm>
+          <a:prstGeom prst="rect">
+            <a:avLst/>
+          </a:prstGeom>
+          <a:noFill/>
+          <a:ln/>
+        </p:spPr>
+        <p:txBody>
+          <a:bodyPr wrap="square" lIns="0" tIns="0" rIns="0" bIns="0" rtlCol="0" anchor="ctr"/>
+          <a:lstStyle/>
+          <a:p>
+            <a:pPr marL="0" indent="0" algn="ctr">
+              <a:buNone/>
+            </a:pPr>
+            <a:r>
+              <a:rPr lang="en-US" sz="1500" b="1" dirty="0">
+                <a:solidFill>
+                  <a:srgbClr val="FFFFFF"/>
+                </a:solidFill>
+                <a:latin typeface="Cambria" pitchFamily="34" charset="0"/>
+                <a:ea typeface="Cambria" pitchFamily="34" charset="-122"/>
+                <a:cs typeface="Cambria" pitchFamily="34" charset="-120"/>
+              </a:rPr>
+              <a:t>24 %</a:t>
+            </a:r>
+            <a:endParaRPr lang="en-US" sz="1500" dirty="0"/>
+          </a:p>
+          <a:p>
+            <a:pPr marL="0" indent="0" algn="ctr">
+              <a:buNone/>
+            </a:pPr>
+            <a:r>
+              <a:rPr lang="en-US" sz="950" dirty="0">
+                <a:solidFill>
+                  <a:srgbClr val="FFFFFF"/>
+                </a:solidFill>
+                <a:latin typeface="Calibri" pitchFamily="34" charset="0"/>
+                <a:ea typeface="Calibri" pitchFamily="34" charset="-122"/>
+                <a:cs typeface="Calibri" pitchFamily="34" charset="-120"/>
+              </a:rPr>
+              <a:t>Divergence nette</a:t>
+            </a:r>
+            <a:endParaRPr lang="en-US" sz="1500" dirty="0"/>
+          </a:p>
+        </p:txBody>
+      </p:sp>
+      <p:sp>
+        <p:nvSpPr>
+          <p:cNvPr id="38" name="Shape 36"/>
+          <p:cNvSpPr/>
+          <p:nvPr/>
+        </p:nvSpPr>
+        <p:spPr>
+          <a:xfrm>
+            <a:off x="7655357" y="4572000"/>
+            <a:ext cx="1799539" cy="777240"/>
+          </a:xfrm>
+          <a:prstGeom prst="rect">
+            <a:avLst/>
+          </a:prstGeom>
+          <a:solidFill>
+            <a:srgbClr val="2F5D8C"/>
+          </a:solidFill>
+          <a:ln/>
+        </p:spPr>
+        <p:txBody>
+          <a:bodyPr/>
+          <a:lstStyle/>
+          <a:p>
+            <a:endParaRPr lang="fr-FR"/>
+          </a:p>
+        </p:txBody>
+      </p:sp>
+      <p:sp>
+        <p:nvSpPr>
+          <p:cNvPr id="39" name="Text 37"/>
+          <p:cNvSpPr/>
+          <p:nvPr/>
+        </p:nvSpPr>
+        <p:spPr>
+          <a:xfrm>
+            <a:off x="7655357" y="4572000"/>
+            <a:ext cx="1799539" cy="777240"/>
+          </a:xfrm>
+          <a:prstGeom prst="rect">
+            <a:avLst/>
+          </a:prstGeom>
+          <a:noFill/>
+          <a:ln/>
+        </p:spPr>
+        <p:txBody>
+          <a:bodyPr wrap="square" lIns="0" tIns="0" rIns="0" bIns="0" rtlCol="0" anchor="ctr"/>
+          <a:lstStyle/>
+          <a:p>
+            <a:pPr marL="0" indent="0" algn="ctr">
+              <a:buNone/>
+            </a:pPr>
+            <a:r>
+              <a:rPr lang="en-US" sz="1500" b="1" dirty="0">
+                <a:solidFill>
+                  <a:srgbClr val="FFFFFF"/>
+                </a:solidFill>
+                <a:latin typeface="Cambria" pitchFamily="34" charset="0"/>
+                <a:ea typeface="Cambria" pitchFamily="34" charset="-122"/>
+                <a:cs typeface="Cambria" pitchFamily="34" charset="-120"/>
+              </a:rPr>
+              <a:t>16 %</a:t>
+            </a:r>
+            <a:endParaRPr lang="en-US" sz="1500" dirty="0"/>
+          </a:p>
+          <a:p>
+            <a:pPr marL="0" indent="0" algn="ctr">
+              <a:buNone/>
+            </a:pPr>
+            <a:r>
+              <a:rPr lang="en-US" sz="950" dirty="0">
+                <a:solidFill>
+                  <a:srgbClr val="FFFFFF"/>
+                </a:solidFill>
+                <a:latin typeface="Calibri" pitchFamily="34" charset="0"/>
+                <a:ea typeface="Calibri" pitchFamily="34" charset="-122"/>
+                <a:cs typeface="Calibri" pitchFamily="34" charset="-120"/>
+              </a:rPr>
+              <a:t>Divergence ambiguë</a:t>
+            </a:r>
+            <a:endParaRPr lang="en-US" sz="1500" dirty="0"/>
+          </a:p>
+        </p:txBody>
+      </p:sp>
+      <p:sp>
+        <p:nvSpPr>
+          <p:cNvPr id="40" name="Shape 38"/>
+          <p:cNvSpPr/>
+          <p:nvPr/>
+        </p:nvSpPr>
+        <p:spPr>
+          <a:xfrm>
+            <a:off x="9454896" y="4572000"/>
+            <a:ext cx="2249424" cy="777240"/>
+          </a:xfrm>
+          <a:prstGeom prst="rect">
+            <a:avLst/>
+          </a:prstGeom>
+          <a:solidFill>
+            <a:srgbClr val="9DCAD2"/>
+          </a:solidFill>
+          <a:ln/>
+        </p:spPr>
+        <p:txBody>
+          <a:bodyPr/>
+          <a:lstStyle/>
+          <a:p>
+            <a:endParaRPr lang="fr-FR"/>
+          </a:p>
+        </p:txBody>
+      </p:sp>
+      <p:sp>
+        <p:nvSpPr>
+          <p:cNvPr id="41" name="Text 39"/>
+          <p:cNvSpPr/>
+          <p:nvPr/>
+        </p:nvSpPr>
+        <p:spPr>
+          <a:xfrm>
+            <a:off x="9454896" y="4572000"/>
+            <a:ext cx="2249424" cy="777240"/>
+          </a:xfrm>
+          <a:prstGeom prst="rect">
+            <a:avLst/>
+          </a:prstGeom>
+          <a:noFill/>
+          <a:ln/>
+        </p:spPr>
+        <p:txBody>
+          <a:bodyPr wrap="square" lIns="0" tIns="0" rIns="0" bIns="0" rtlCol="0" anchor="ctr"/>
+          <a:lstStyle/>
+          <a:p>
+            <a:pPr marL="0" indent="0" algn="ctr">
+              <a:buNone/>
+            </a:pPr>
+            <a:r>
+              <a:rPr lang="en-US" sz="1500" b="1" dirty="0">
+                <a:solidFill>
+                  <a:srgbClr val="14264A"/>
+                </a:solidFill>
+                <a:latin typeface="Cambria" pitchFamily="34" charset="0"/>
+                <a:ea typeface="Cambria" pitchFamily="34" charset="-122"/>
+                <a:cs typeface="Cambria" pitchFamily="34" charset="-120"/>
+              </a:rPr>
+              <a:t>20 %</a:t>
+            </a:r>
+            <a:endParaRPr lang="en-US" sz="1500" dirty="0"/>
+          </a:p>
+          <a:p>
+            <a:pPr marL="0" indent="0" algn="ctr">
+              <a:buNone/>
+            </a:pPr>
+            <a:r>
+              <a:rPr lang="en-US" sz="950" dirty="0">
+                <a:solidFill>
+                  <a:srgbClr val="14264A"/>
+                </a:solidFill>
+                <a:latin typeface="Calibri" pitchFamily="34" charset="0"/>
+                <a:ea typeface="Calibri" pitchFamily="34" charset="-122"/>
+                <a:cs typeface="Calibri" pitchFamily="34" charset="-120"/>
+              </a:rPr>
+              <a:t>Même famille</a:t>
+            </a:r>
+            <a:endParaRPr lang="en-US" sz="1500" dirty="0"/>
+          </a:p>
+        </p:txBody>
+      </p:sp>
+      <p:sp>
+        <p:nvSpPr>
+          <p:cNvPr id="42" name="Text 40"/>
+          <p:cNvSpPr/>
+          <p:nvPr/>
+        </p:nvSpPr>
+        <p:spPr>
+          <a:xfrm>
+            <a:off x="457200" y="5513832"/>
+            <a:ext cx="11247120" cy="457200"/>
+          </a:xfrm>
+          <a:prstGeom prst="rect">
+            <a:avLst/>
+          </a:prstGeom>
+          <a:noFill/>
+          <a:ln/>
+        </p:spPr>
+        <p:txBody>
+          <a:bodyPr wrap="square" lIns="0" tIns="0" rIns="0" bIns="0" rtlCol="0" anchor="ctr"/>
+          <a:lstStyle/>
+          <a:p>
+            <a:pPr marL="0" indent="0" algn="l">
+              <a:buNone/>
+            </a:pPr>
+            <a:r>
+              <a:rPr lang="en-US" sz="1100" i="1" dirty="0">
+                <a:solidFill>
+                  <a:srgbClr val="5A6572"/>
+                </a:solidFill>
+                <a:latin typeface="Calibri" pitchFamily="34" charset="0"/>
+                <a:ea typeface="Calibri" pitchFamily="34" charset="-122"/>
+                <a:cs typeface="Calibri" pitchFamily="34" charset="-120"/>
+              </a:rPr>
+              <a:t>Parmi les familles différentes (80 %), le rapport 40:24:16 correspond au 50:30:20 par difficulté. Les 20 % restants sont des cas de même famille, plus difficiles.</a:t>
+            </a:r>
+            <a:endParaRPr lang="en-US" sz="1100" dirty="0"/>
+          </a:p>
+        </p:txBody>
+      </p:sp>
+      <p:sp>
+        <p:nvSpPr>
+          <p:cNvPr id="43" name="Slide Number Placeholder 0">
+            <a:extLst>
+              <a:ext uri="{FF2B5EF4-FFF2-40B4-BE49-F238E27FC236}">
+                <a16:creationId xmlns:a16="http://schemas.microsoft.com/office/drawing/2014/main" id="{4F97D055-CFC4-2527-27BE-2ADF766D7D47}"/>
+              </a:ext>
+            </a:extLst>
+          </p:cNvPr>
+          <p:cNvSpPr>
+            <a:spLocks noGrp="1"/>
+          </p:cNvSpPr>
+          <p:nvPr>
+            <p:ph type="sldNum" sz="quarter" idx="4294967295"/>
+          </p:nvPr>
+        </p:nvSpPr>
+        <p:spPr>
+          <a:xfrm>
+            <a:off x="11430000" y="6455664"/>
+            <a:ext cx="640080" cy="274320"/>
+          </a:xfrm>
+          <a:prstGeom prst="rect">
+            <a:avLst/>
+          </a:prstGeom>
+          <a:extLst>
+            <a:ext uri="{C572A759-6A51-4108-AA02-DFA0A04FC94B}">
+              <ma14:wrappingTextBoxFlag xmlns="" xmlns:ma14="http://schemas.microsoft.com/office/mac/drawingml/2011/main" val="0"/>
+            </a:ext>
+          </a:extLst>
+        </p:spPr>
+        <p:txBody>
+          <a:bodyPr/>
+          <a:lstStyle>
+            <a:lvl1pPr>
+              <a:defRPr sz="1000">
+                <a:solidFill>
+                  <a:srgbClr val="5E6E7E"/>
+                </a:solidFill>
+                <a:latin typeface="Calibri"/>
+                <a:ea typeface="Calibri"/>
+                <a:cs typeface="Calibri"/>
+              </a:defRPr>
+            </a:lvl1pPr>
+          </a:lstStyle>
+          <a:p>
+            <a:pPr algn="r"/>
+            <a:fld id="{F7021451-1387-4CA6-816F-3879F97B5CBC}" type="slidenum">
+              <a:rPr lang="fr-FR" b="0" noProof="0" smtClean="0"/>
+              <a:t>7</a:t>
+            </a:fld>
+            <a:endParaRPr lang="fr-FR" noProof="0" dirty="0"/>
+          </a:p>
+        </p:txBody>
+      </p:sp>
+    </p:spTree>
+  </p:cSld>
+  <p:clrMapOvr>
+    <a:masterClrMapping/>
+  </p:clrMapOvr>
+</p:sld>
+</file>
+
+<file path=ppt/slides/slide8.xml><?xml version="1.0" encoding="utf-8"?>
 <p:sld xmlns:a="http://schemas.openxmlformats.org/drawingml/2006/main" xmlns:r="http://schemas.openxmlformats.org/officeDocument/2006/relationships" xmlns:p="http://schemas.openxmlformats.org/presentationml/2006/main">
   <p:cSld name="Slide 6">
     <p:bg>
@@ -9769,8 +11858,8 @@
         </p:nvSpPr>
         <p:spPr>
           <a:xfrm>
-            <a:off x="7150000" y="2320000"/>
-            <a:ext cx="3700000" cy="2760000"/>
+            <a:off x="7150000" y="2046364"/>
+            <a:ext cx="4310480" cy="3033636"/>
           </a:xfrm>
           <a:prstGeom prst="roundRect">
             <a:avLst>
@@ -9805,7 +11894,7 @@
         </p:nvSpPr>
         <p:spPr>
           <a:xfrm>
-            <a:off x="7300000" y="2440000"/>
+            <a:off x="7300000" y="2204336"/>
             <a:ext cx="3400000" cy="280000"/>
           </a:xfrm>
           <a:prstGeom prst="rect">
@@ -9852,8 +11941,8 @@
         </p:blipFill>
         <p:spPr>
           <a:xfrm>
-            <a:off x="7469500" y="2780000"/>
-            <a:ext cx="3061000" cy="2220000"/>
+            <a:off x="7469499" y="2534140"/>
+            <a:ext cx="3399999" cy="2465860"/>
           </a:xfrm>
           <a:prstGeom prst="rect">
             <a:avLst/>
@@ -10046,7 +12135,7 @@
           </a:prstGeom>
           <a:extLst>
             <a:ext uri="{C572A759-6A51-4108-AA02-DFA0A04FC94B}">
-              <ma14:wrappingTextBoxFlag xmlns:ma14="http://schemas.microsoft.com/office/mac/drawingml/2011/main" xmlns="" val="0"/>
+              <ma14:wrappingTextBoxFlag xmlns="" xmlns:ma14="http://schemas.microsoft.com/office/mac/drawingml/2011/main" val="0"/>
             </a:ext>
           </a:extLst>
         </p:spPr>
@@ -10068,7 +12157,7 @@
             <a:pPr algn="r"/>
             <a:fld id="{F7021451-1387-4CA6-816F-3879F97B5CBC}" type="slidenum">
               <a:rPr lang="fr-FR" b="0" noProof="0" smtClean="0"/>
-              <a:t>7</a:t>
+              <a:t>8</a:t>
             </a:fld>
             <a:endParaRPr lang="fr-FR" noProof="0" dirty="0"/>
           </a:p>
@@ -10082,7 +12171,7 @@
 </p:sld>
 </file>
 
-<file path=ppt/slides/slide8.xml><?xml version="1.0" encoding="utf-8"?>
+<file path=ppt/slides/slide9.xml><?xml version="1.0" encoding="utf-8"?>
 <p:sld xmlns:a="http://schemas.openxmlformats.org/drawingml/2006/main" xmlns:r="http://schemas.openxmlformats.org/officeDocument/2006/relationships" xmlns:p="http://schemas.openxmlformats.org/presentationml/2006/main">
   <p:cSld>
     <p:spTree>
@@ -11384,7 +13473,7 @@
           </a:prstGeom>
           <a:extLst>
             <a:ext uri="{C572A759-6A51-4108-AA02-DFA0A04FC94B}">
-              <ma14:wrappingTextBoxFlag xmlns:ma14="http://schemas.microsoft.com/office/mac/drawingml/2011/main" xmlns="" val="0"/>
+              <ma14:wrappingTextBoxFlag xmlns="" xmlns:ma14="http://schemas.microsoft.com/office/mac/drawingml/2011/main" val="0"/>
             </a:ext>
           </a:extLst>
         </p:spPr>
@@ -11406,7 +13495,7 @@
             <a:pPr algn="r"/>
             <a:fld id="{F7021451-1387-4CA6-816F-3879F97B5CBC}" type="slidenum">
               <a:rPr lang="fr-FR" b="0" noProof="0" smtClean="0"/>
-              <a:t>8</a:t>
+              <a:t>9</a:t>
             </a:fld>
             <a:endParaRPr lang="fr-FR" noProof="0" dirty="0"/>
           </a:p>
@@ -12543,390 +14632,6 @@
 </p:sld>
 </file>
 
-<file path=ppt/slides/slide9.xml><?xml version="1.0" encoding="utf-8"?>
-<p:sld xmlns:a="http://schemas.openxmlformats.org/drawingml/2006/main" xmlns:r="http://schemas.openxmlformats.org/officeDocument/2006/relationships" xmlns:p="http://schemas.openxmlformats.org/presentationml/2006/main">
-  <p:cSld>
-    <p:spTree>
-      <p:nvGrpSpPr>
-        <p:cNvPr id="1" name="">
-          <a:extLst>
-            <a:ext uri="{FF2B5EF4-FFF2-40B4-BE49-F238E27FC236}">
-              <a16:creationId xmlns:a16="http://schemas.microsoft.com/office/drawing/2014/main" id="{EA162FD1-BD63-AE73-F8C5-B545DA785195}"/>
-            </a:ext>
-          </a:extLst>
-        </p:cNvPr>
-        <p:cNvGrpSpPr/>
-        <p:nvPr/>
-      </p:nvGrpSpPr>
-      <p:grpSpPr>
-        <a:xfrm>
-          <a:off x="0" y="0"/>
-          <a:ext cx="0" cy="0"/>
-          <a:chOff x="0" y="0"/>
-          <a:chExt cx="0" cy="0"/>
-        </a:xfrm>
-      </p:grpSpPr>
-      <p:sp>
-        <p:nvSpPr>
-          <p:cNvPr id="2" name="Shape 0">
-            <a:extLst>
-              <a:ext uri="{FF2B5EF4-FFF2-40B4-BE49-F238E27FC236}">
-                <a16:creationId xmlns:a16="http://schemas.microsoft.com/office/drawing/2014/main" id="{30540348-C0CF-1E07-7141-23FB128D2A42}"/>
-              </a:ext>
-            </a:extLst>
-          </p:cNvPr>
-          <p:cNvSpPr/>
-          <p:nvPr/>
-        </p:nvSpPr>
-        <p:spPr>
-          <a:xfrm>
-            <a:off x="566928" y="457200"/>
-            <a:ext cx="658368" cy="658368"/>
-          </a:xfrm>
-          <a:prstGeom prst="ellipse">
-            <a:avLst/>
-          </a:prstGeom>
-          <a:solidFill>
-            <a:srgbClr val="1FA8B8"/>
-          </a:solidFill>
-          <a:ln/>
-        </p:spPr>
-        <p:txBody>
-          <a:bodyPr/>
-          <a:lstStyle/>
-          <a:p>
-            <a:endParaRPr lang="fr-FR" noProof="0" dirty="0"/>
-          </a:p>
-        </p:txBody>
-      </p:sp>
-      <p:pic>
-        <p:nvPicPr>
-          <p:cNvPr id="3" name="Image 0" descr="preencoded.png">
-            <a:extLst>
-              <a:ext uri="{FF2B5EF4-FFF2-40B4-BE49-F238E27FC236}">
-                <a16:creationId xmlns:a16="http://schemas.microsoft.com/office/drawing/2014/main" id="{F3ADC3F1-8C17-5F39-0FE5-46BFE49A73B6}"/>
-              </a:ext>
-            </a:extLst>
-          </p:cNvPr>
-          <p:cNvPicPr>
-            <a:picLocks noChangeAspect="1"/>
-          </p:cNvPicPr>
-          <p:nvPr/>
-        </p:nvPicPr>
-        <p:blipFill>
-          <a:blip r:embed="rId3"/>
-          <a:stretch>
-            <a:fillRect/>
-          </a:stretch>
-        </p:blipFill>
-        <p:spPr>
-          <a:xfrm>
-            <a:off x="731520" y="621792"/>
-            <a:ext cx="329184" cy="329184"/>
-          </a:xfrm>
-          <a:prstGeom prst="rect">
-            <a:avLst/>
-          </a:prstGeom>
-        </p:spPr>
-      </p:pic>
-      <p:sp>
-        <p:nvSpPr>
-          <p:cNvPr id="4" name="Text 1">
-            <a:extLst>
-              <a:ext uri="{FF2B5EF4-FFF2-40B4-BE49-F238E27FC236}">
-                <a16:creationId xmlns:a16="http://schemas.microsoft.com/office/drawing/2014/main" id="{B74649CF-524E-1554-2185-05874BAF25DB}"/>
-              </a:ext>
-            </a:extLst>
-          </p:cNvPr>
-          <p:cNvSpPr/>
-          <p:nvPr/>
-        </p:nvSpPr>
-        <p:spPr>
-          <a:xfrm>
-            <a:off x="1417320" y="420624"/>
-            <a:ext cx="10241280" cy="274320"/>
-          </a:xfrm>
-          <a:prstGeom prst="rect">
-            <a:avLst/>
-          </a:prstGeom>
-          <a:noFill/>
-          <a:ln/>
-        </p:spPr>
-        <p:txBody>
-          <a:bodyPr wrap="square" lIns="0" tIns="0" rIns="0" bIns="0" rtlCol="0" anchor="ctr"/>
-          <a:lstStyle/>
-          <a:p>
-            <a:pPr marL="0" indent="0">
-              <a:buNone/>
-            </a:pPr>
-            <a:r>
-              <a:rPr lang="fr-FR" sz="1100" b="1" kern="0" spc="200" noProof="0" dirty="0">
-                <a:solidFill>
-                  <a:srgbClr val="12798A"/>
-                </a:solidFill>
-                <a:latin typeface="Calibri" pitchFamily="34" charset="0"/>
-                <a:ea typeface="Calibri" pitchFamily="34" charset="-122"/>
-                <a:cs typeface="Calibri" pitchFamily="34" charset="-120"/>
-              </a:rPr>
-              <a:t>SECTION 05 - CE QUE RACONTENT LES CHIFFRES</a:t>
-            </a:r>
-            <a:endParaRPr lang="fr-FR" sz="1100" noProof="0" dirty="0"/>
-          </a:p>
-        </p:txBody>
-      </p:sp>
-      <p:sp>
-        <p:nvSpPr>
-          <p:cNvPr id="5" name="Text 2">
-            <a:extLst>
-              <a:ext uri="{FF2B5EF4-FFF2-40B4-BE49-F238E27FC236}">
-                <a16:creationId xmlns:a16="http://schemas.microsoft.com/office/drawing/2014/main" id="{3985DFBF-F171-091E-AD37-EA7008BA044D}"/>
-              </a:ext>
-            </a:extLst>
-          </p:cNvPr>
-          <p:cNvSpPr/>
-          <p:nvPr/>
-        </p:nvSpPr>
-        <p:spPr>
-          <a:xfrm>
-            <a:off x="1417320" y="658368"/>
-            <a:ext cx="10241280" cy="566928"/>
-          </a:xfrm>
-          <a:prstGeom prst="rect">
-            <a:avLst/>
-          </a:prstGeom>
-          <a:noFill/>
-          <a:ln/>
-        </p:spPr>
-        <p:txBody>
-          <a:bodyPr wrap="square" lIns="0" tIns="0" rIns="0" bIns="0" rtlCol="0" anchor="ctr"/>
-          <a:lstStyle/>
-          <a:p>
-            <a:pPr marL="0" indent="0">
-              <a:buNone/>
-            </a:pPr>
-            <a:r>
-              <a:rPr lang="fr-FR" sz="2700" b="1" noProof="0" dirty="0">
-                <a:solidFill>
-                  <a:srgbClr val="16243F"/>
-                </a:solidFill>
-                <a:latin typeface="Cambria" pitchFamily="34" charset="0"/>
-                <a:ea typeface="Cambria" pitchFamily="34" charset="-122"/>
-              </a:rPr>
-              <a:t>Matrices de confusion</a:t>
-            </a:r>
-            <a:endParaRPr lang="fr-FR" sz="2700" noProof="0" dirty="0"/>
-          </a:p>
-        </p:txBody>
-      </p:sp>
-      <p:sp>
-        <p:nvSpPr>
-          <p:cNvPr id="6" name="Text 3">
-            <a:extLst>
-              <a:ext uri="{FF2B5EF4-FFF2-40B4-BE49-F238E27FC236}">
-                <a16:creationId xmlns:a16="http://schemas.microsoft.com/office/drawing/2014/main" id="{29213612-5A48-59B7-BD43-E07D3A582AC7}"/>
-              </a:ext>
-            </a:extLst>
-          </p:cNvPr>
-          <p:cNvSpPr/>
-          <p:nvPr/>
-        </p:nvSpPr>
-        <p:spPr>
-          <a:xfrm>
-            <a:off x="2394483" y="1600200"/>
-            <a:ext cx="2147217" cy="365760"/>
-          </a:xfrm>
-          <a:prstGeom prst="rect">
-            <a:avLst/>
-          </a:prstGeom>
-          <a:noFill/>
-          <a:ln/>
-        </p:spPr>
-        <p:txBody>
-          <a:bodyPr wrap="square" lIns="0" tIns="0" rIns="0" bIns="0" rtlCol="0" anchor="ctr"/>
-          <a:lstStyle/>
-          <a:p>
-            <a:r>
-              <a:rPr lang="fr-FR" sz="1600" b="1">
-                <a:solidFill>
-                  <a:srgbClr val="16243F"/>
-                </a:solidFill>
-                <a:latin typeface="Cambria"/>
-                <a:ea typeface="Cambria"/>
-              </a:rPr>
-              <a:t>La similarité</a:t>
-            </a:r>
-            <a:endParaRPr lang="fr-FR" sz="1600" noProof="0" dirty="0"/>
-          </a:p>
-        </p:txBody>
-      </p:sp>
-      <p:sp>
-        <p:nvSpPr>
-          <p:cNvPr id="25" name="Slide Number Placeholder 0">
-            <a:extLst>
-              <a:ext uri="{FF2B5EF4-FFF2-40B4-BE49-F238E27FC236}">
-                <a16:creationId xmlns:a16="http://schemas.microsoft.com/office/drawing/2014/main" id="{A20053B0-029D-DAAB-9131-2B7ECA3C456A}"/>
-              </a:ext>
-            </a:extLst>
-          </p:cNvPr>
-          <p:cNvSpPr>
-            <a:spLocks noGrp="1"/>
-          </p:cNvSpPr>
-          <p:nvPr>
-            <p:ph type="sldNum" sz="quarter" idx="4294967295"/>
-          </p:nvPr>
-        </p:nvSpPr>
-        <p:spPr>
-          <a:xfrm>
-            <a:off x="11430000" y="6455664"/>
-            <a:ext cx="640080" cy="274320"/>
-          </a:xfrm>
-          <a:prstGeom prst="rect">
-            <a:avLst/>
-          </a:prstGeom>
-          <a:extLst>
-            <a:ext uri="{C572A759-6A51-4108-AA02-DFA0A04FC94B}">
-              <ma14:wrappingTextBoxFlag xmlns:ma14="http://schemas.microsoft.com/office/mac/drawingml/2011/main" xmlns="" val="0"/>
-            </a:ext>
-          </a:extLst>
-        </p:spPr>
-        <p:txBody>
-          <a:bodyPr/>
-          <a:lstStyle>
-            <a:lvl1pPr>
-              <a:defRPr sz="1000">
-                <a:solidFill>
-                  <a:srgbClr val="5E6E7E"/>
-                </a:solidFill>
-                <a:latin typeface="Calibri"/>
-                <a:ea typeface="Calibri"/>
-                <a:cs typeface="Calibri"/>
-              </a:defRPr>
-            </a:lvl1pPr>
-          </a:lstStyle>
-          <a:p>
-            <a:pPr algn="r"/>
-            <a:fld id="{F7021451-1387-4CA6-816F-3879F97B5CBC}" type="slidenum">
-              <a:rPr lang="fr-FR" b="0" noProof="0" smtClean="0"/>
-              <a:t>9</a:t>
-            </a:fld>
-            <a:endParaRPr lang="fr-FR" noProof="0" dirty="0"/>
-          </a:p>
-        </p:txBody>
-      </p:sp>
-      <p:sp>
-        <p:nvSpPr>
-          <p:cNvPr id="7" name="Text 3">
-            <a:extLst>
-              <a:ext uri="{FF2B5EF4-FFF2-40B4-BE49-F238E27FC236}">
-                <a16:creationId xmlns:a16="http://schemas.microsoft.com/office/drawing/2014/main" id="{A018F4DE-35D8-F33F-5DEC-5623FC02AF6C}"/>
-              </a:ext>
-            </a:extLst>
-          </p:cNvPr>
-          <p:cNvSpPr/>
-          <p:nvPr/>
-        </p:nvSpPr>
-        <p:spPr>
-          <a:xfrm>
-            <a:off x="8066117" y="1600200"/>
-            <a:ext cx="1627728" cy="365760"/>
-          </a:xfrm>
-          <a:prstGeom prst="rect">
-            <a:avLst/>
-          </a:prstGeom>
-          <a:noFill/>
-          <a:ln/>
-        </p:spPr>
-        <p:txBody>
-          <a:bodyPr wrap="square" lIns="0" tIns="0" rIns="0" bIns="0" rtlCol="0" anchor="ctr"/>
-          <a:lstStyle/>
-          <a:p>
-            <a:r>
-              <a:rPr lang="fr-FR" sz="1600" b="1">
-                <a:solidFill>
-                  <a:srgbClr val="16243F"/>
-                </a:solidFill>
-                <a:latin typeface="Cambria"/>
-                <a:ea typeface="Cambria"/>
-              </a:rPr>
-              <a:t>Cross Attention</a:t>
-            </a:r>
-            <a:endParaRPr lang="fr-FR" sz="1600" noProof="0" dirty="0"/>
-          </a:p>
-        </p:txBody>
-      </p:sp>
-      <p:pic>
-        <p:nvPicPr>
-          <p:cNvPr id="8" name="Image 7" descr="Une image contenant texte, capture d’écran, Police, diagramme  Le contenu généré par l’IA peut être incorrect.">
-            <a:extLst>
-              <a:ext uri="{FF2B5EF4-FFF2-40B4-BE49-F238E27FC236}">
-                <a16:creationId xmlns:a16="http://schemas.microsoft.com/office/drawing/2014/main" id="{8931718B-D51E-AD6A-231B-854AF1B76B72}"/>
-              </a:ext>
-            </a:extLst>
-          </p:cNvPr>
-          <p:cNvPicPr>
-            <a:picLocks noChangeAspect="1"/>
-          </p:cNvPicPr>
-          <p:nvPr/>
-        </p:nvPicPr>
-        <p:blipFill>
-          <a:blip r:embed="rId4"/>
-          <a:stretch>
-            <a:fillRect/>
-          </a:stretch>
-        </p:blipFill>
-        <p:spPr>
-          <a:xfrm>
-            <a:off x="1088988" y="2062743"/>
-            <a:ext cx="3908734" cy="3829050"/>
-          </a:xfrm>
-          <a:prstGeom prst="rect">
-            <a:avLst/>
-          </a:prstGeom>
-        </p:spPr>
-      </p:pic>
-      <p:pic>
-        <p:nvPicPr>
-          <p:cNvPr id="9" name="Image 8" descr="Une image contenant texte, capture d’écran, Police, nombre  Le contenu généré par l’IA peut être incorrect.">
-            <a:extLst>
-              <a:ext uri="{FF2B5EF4-FFF2-40B4-BE49-F238E27FC236}">
-                <a16:creationId xmlns:a16="http://schemas.microsoft.com/office/drawing/2014/main" id="{9245F59E-EA40-E3E2-8B7E-868F32C57DBD}"/>
-              </a:ext>
-            </a:extLst>
-          </p:cNvPr>
-          <p:cNvPicPr>
-            <a:picLocks noChangeAspect="1"/>
-          </p:cNvPicPr>
-          <p:nvPr/>
-        </p:nvPicPr>
-        <p:blipFill>
-          <a:blip r:embed="rId5"/>
-          <a:stretch>
-            <a:fillRect/>
-          </a:stretch>
-        </p:blipFill>
-        <p:spPr>
-          <a:xfrm>
-            <a:off x="6746837" y="2059375"/>
-            <a:ext cx="4255351" cy="3724275"/>
-          </a:xfrm>
-          <a:prstGeom prst="rect">
-            <a:avLst/>
-          </a:prstGeom>
-        </p:spPr>
-      </p:pic>
-    </p:spTree>
-    <p:extLst>
-      <p:ext uri="{BB962C8B-B14F-4D97-AF65-F5344CB8AC3E}">
-        <p14:creationId xmlns:p14="http://schemas.microsoft.com/office/powerpoint/2010/main" val="3567918940"/>
-      </p:ext>
-    </p:extLst>
-  </p:cSld>
-  <p:clrMapOvr>
-    <a:masterClrMapping/>
-  </p:clrMapOvr>
-</p:sld>
-</file>
-
 <file path=ppt/theme/theme1.xml><?xml version="1.0" encoding="utf-8"?>
 <a:theme xmlns:a="http://schemas.openxmlformats.org/drawingml/2006/main" name="Office Theme">
   <a:themeElements>

</xml_diff>